<commit_message>
Refactored week 1 demos and excerices
</commit_message>
<xml_diff>
--- a/slides/PS4106_lecture1_Intro.pptx
+++ b/slides/PS4106_lecture1_Intro.pptx
@@ -6,37 +6,40 @@
     <p:sldMasterId id="2147483673" r:id="rId2"/>
   </p:sldMasterIdLst>
   <p:notesMasterIdLst>
-    <p:notesMasterId r:id="rId31"/>
+    <p:notesMasterId r:id="rId34"/>
   </p:notesMasterIdLst>
   <p:sldIdLst>
     <p:sldId id="256" r:id="rId3"/>
-    <p:sldId id="357" r:id="rId4"/>
-    <p:sldId id="359" r:id="rId5"/>
-    <p:sldId id="360" r:id="rId6"/>
-    <p:sldId id="361" r:id="rId7"/>
-    <p:sldId id="362" r:id="rId8"/>
-    <p:sldId id="363" r:id="rId9"/>
-    <p:sldId id="364" r:id="rId10"/>
-    <p:sldId id="365" r:id="rId11"/>
-    <p:sldId id="366" r:id="rId12"/>
-    <p:sldId id="367" r:id="rId13"/>
-    <p:sldId id="369" r:id="rId14"/>
-    <p:sldId id="370" r:id="rId15"/>
-    <p:sldId id="371" r:id="rId16"/>
-    <p:sldId id="368" r:id="rId17"/>
-    <p:sldId id="355" r:id="rId18"/>
-    <p:sldId id="356" r:id="rId19"/>
-    <p:sldId id="258" r:id="rId20"/>
-    <p:sldId id="259" r:id="rId21"/>
-    <p:sldId id="263" r:id="rId22"/>
-    <p:sldId id="265" r:id="rId23"/>
-    <p:sldId id="266" r:id="rId24"/>
-    <p:sldId id="372" r:id="rId25"/>
-    <p:sldId id="373" r:id="rId26"/>
-    <p:sldId id="267" r:id="rId27"/>
-    <p:sldId id="268" r:id="rId28"/>
-    <p:sldId id="276" r:id="rId29"/>
+    <p:sldId id="359" r:id="rId4"/>
+    <p:sldId id="360" r:id="rId5"/>
+    <p:sldId id="361" r:id="rId6"/>
+    <p:sldId id="362" r:id="rId7"/>
+    <p:sldId id="363" r:id="rId8"/>
+    <p:sldId id="364" r:id="rId9"/>
+    <p:sldId id="365" r:id="rId10"/>
+    <p:sldId id="366" r:id="rId11"/>
+    <p:sldId id="367" r:id="rId12"/>
+    <p:sldId id="369" r:id="rId13"/>
+    <p:sldId id="370" r:id="rId14"/>
+    <p:sldId id="371" r:id="rId15"/>
+    <p:sldId id="368" r:id="rId16"/>
+    <p:sldId id="355" r:id="rId17"/>
+    <p:sldId id="356" r:id="rId18"/>
+    <p:sldId id="258" r:id="rId19"/>
+    <p:sldId id="265" r:id="rId20"/>
+    <p:sldId id="266" r:id="rId21"/>
+    <p:sldId id="372" r:id="rId22"/>
+    <p:sldId id="373" r:id="rId23"/>
+    <p:sldId id="267" r:id="rId24"/>
+    <p:sldId id="268" r:id="rId25"/>
+    <p:sldId id="276" r:id="rId26"/>
+    <p:sldId id="259" r:id="rId27"/>
+    <p:sldId id="376" r:id="rId28"/>
+    <p:sldId id="374" r:id="rId29"/>
     <p:sldId id="358" r:id="rId30"/>
+    <p:sldId id="377" r:id="rId31"/>
+    <p:sldId id="375" r:id="rId32"/>
+    <p:sldId id="379" r:id="rId33"/>
   </p:sldIdLst>
   <p:sldSz cx="13004800" cy="9753600"/>
   <p:notesSz cx="6858000" cy="9144000"/>
@@ -596,6 +599,207 @@
 </p:notes>
 </file>
 
+<file path=ppt/notesSlides/notesSlide10.xml><?xml version="1.0" encoding="utf-8"?>
+<p:notes xmlns:a="http://schemas.openxmlformats.org/drawingml/2006/main" xmlns:r="http://schemas.openxmlformats.org/officeDocument/2006/relationships" xmlns:p="http://schemas.openxmlformats.org/presentationml/2006/main">
+  <p:cSld>
+    <p:spTree>
+      <p:nvGrpSpPr>
+        <p:cNvPr id="1" name=""/>
+        <p:cNvGrpSpPr/>
+        <p:nvPr/>
+      </p:nvGrpSpPr>
+      <p:grpSpPr>
+        <a:xfrm>
+          <a:off x="0" y="0"/>
+          <a:ext cx="0" cy="0"/>
+          <a:chOff x="0" y="0"/>
+          <a:chExt cx="0" cy="0"/>
+        </a:xfrm>
+      </p:grpSpPr>
+      <p:sp>
+        <p:nvSpPr>
+          <p:cNvPr id="2" name="Slide Image Placeholder 1"/>
+          <p:cNvSpPr>
+            <a:spLocks noGrp="1" noRot="1" noChangeAspect="1"/>
+          </p:cNvSpPr>
+          <p:nvPr>
+            <p:ph type="sldImg"/>
+          </p:nvPr>
+        </p:nvSpPr>
+        <p:spPr/>
+      </p:sp>
+      <p:sp>
+        <p:nvSpPr>
+          <p:cNvPr id="3" name="Notes Placeholder 2"/>
+          <p:cNvSpPr>
+            <a:spLocks noGrp="1"/>
+          </p:cNvSpPr>
+          <p:nvPr>
+            <p:ph type="body" idx="1"/>
+          </p:nvPr>
+        </p:nvSpPr>
+        <p:spPr/>
+        <p:txBody>
+          <a:bodyPr/>
+          <a:lstStyle/>
+          <a:p>
+            <a:endParaRPr lang="en-US" dirty="0"/>
+          </a:p>
+        </p:txBody>
+      </p:sp>
+    </p:spTree>
+    <p:extLst>
+      <p:ext uri="{BB962C8B-B14F-4D97-AF65-F5344CB8AC3E}">
+        <p14:creationId xmlns:p14="http://schemas.microsoft.com/office/powerpoint/2010/main" val="3120254648"/>
+      </p:ext>
+    </p:extLst>
+  </p:cSld>
+  <p:clrMapOvr>
+    <a:masterClrMapping/>
+  </p:clrMapOvr>
+</p:notes>
+</file>
+
+<file path=ppt/notesSlides/notesSlide11.xml><?xml version="1.0" encoding="utf-8"?>
+<p:notes xmlns:a="http://schemas.openxmlformats.org/drawingml/2006/main" xmlns:r="http://schemas.openxmlformats.org/officeDocument/2006/relationships" xmlns:p="http://schemas.openxmlformats.org/presentationml/2006/main">
+  <p:cSld>
+    <p:spTree>
+      <p:nvGrpSpPr>
+        <p:cNvPr id="1" name="">
+          <a:extLst>
+            <a:ext uri="{FF2B5EF4-FFF2-40B4-BE49-F238E27FC236}">
+              <a16:creationId xmlns:a16="http://schemas.microsoft.com/office/drawing/2014/main" id="{65C2EE89-F002-8ADF-F91F-0164D6B0E678}"/>
+            </a:ext>
+          </a:extLst>
+        </p:cNvPr>
+        <p:cNvGrpSpPr/>
+        <p:nvPr/>
+      </p:nvGrpSpPr>
+      <p:grpSpPr>
+        <a:xfrm>
+          <a:off x="0" y="0"/>
+          <a:ext cx="0" cy="0"/>
+          <a:chOff x="0" y="0"/>
+          <a:chExt cx="0" cy="0"/>
+        </a:xfrm>
+      </p:grpSpPr>
+      <p:sp>
+        <p:nvSpPr>
+          <p:cNvPr id="2" name="Slide Image Placeholder 1">
+            <a:extLst>
+              <a:ext uri="{FF2B5EF4-FFF2-40B4-BE49-F238E27FC236}">
+                <a16:creationId xmlns:a16="http://schemas.microsoft.com/office/drawing/2014/main" id="{F7C56AD7-3F2B-3903-A588-9207B3E821AD}"/>
+              </a:ext>
+            </a:extLst>
+          </p:cNvPr>
+          <p:cNvSpPr>
+            <a:spLocks noGrp="1" noRot="1" noChangeAspect="1"/>
+          </p:cNvSpPr>
+          <p:nvPr>
+            <p:ph type="sldImg"/>
+          </p:nvPr>
+        </p:nvSpPr>
+        <p:spPr/>
+      </p:sp>
+      <p:sp>
+        <p:nvSpPr>
+          <p:cNvPr id="3" name="Notes Placeholder 2">
+            <a:extLst>
+              <a:ext uri="{FF2B5EF4-FFF2-40B4-BE49-F238E27FC236}">
+                <a16:creationId xmlns:a16="http://schemas.microsoft.com/office/drawing/2014/main" id="{35ACB8F3-D8AC-2BEF-9DB4-65A6E9114C05}"/>
+              </a:ext>
+            </a:extLst>
+          </p:cNvPr>
+          <p:cNvSpPr>
+            <a:spLocks noGrp="1"/>
+          </p:cNvSpPr>
+          <p:nvPr>
+            <p:ph type="body" idx="1"/>
+          </p:nvPr>
+        </p:nvSpPr>
+        <p:spPr/>
+        <p:txBody>
+          <a:bodyPr/>
+          <a:lstStyle/>
+          <a:p>
+            <a:endParaRPr lang="en-US" dirty="0"/>
+          </a:p>
+        </p:txBody>
+      </p:sp>
+    </p:spTree>
+    <p:extLst>
+      <p:ext uri="{BB962C8B-B14F-4D97-AF65-F5344CB8AC3E}">
+        <p14:creationId xmlns:p14="http://schemas.microsoft.com/office/powerpoint/2010/main" val="2767432917"/>
+      </p:ext>
+    </p:extLst>
+  </p:cSld>
+  <p:clrMapOvr>
+    <a:masterClrMapping/>
+  </p:clrMapOvr>
+</p:notes>
+</file>
+
+<file path=ppt/notesSlides/notesSlide12.xml><?xml version="1.0" encoding="utf-8"?>
+<p:notes xmlns:a="http://schemas.openxmlformats.org/drawingml/2006/main" xmlns:r="http://schemas.openxmlformats.org/officeDocument/2006/relationships" xmlns:p="http://schemas.openxmlformats.org/presentationml/2006/main">
+  <p:cSld>
+    <p:spTree>
+      <p:nvGrpSpPr>
+        <p:cNvPr id="1" name=""/>
+        <p:cNvGrpSpPr/>
+        <p:nvPr/>
+      </p:nvGrpSpPr>
+      <p:grpSpPr>
+        <a:xfrm>
+          <a:off x="0" y="0"/>
+          <a:ext cx="0" cy="0"/>
+          <a:chOff x="0" y="0"/>
+          <a:chExt cx="0" cy="0"/>
+        </a:xfrm>
+      </p:grpSpPr>
+      <p:sp>
+        <p:nvSpPr>
+          <p:cNvPr id="2" name="Slide Image Placeholder 1"/>
+          <p:cNvSpPr>
+            <a:spLocks noGrp="1" noRot="1" noChangeAspect="1"/>
+          </p:cNvSpPr>
+          <p:nvPr>
+            <p:ph type="sldImg"/>
+          </p:nvPr>
+        </p:nvSpPr>
+        <p:spPr/>
+      </p:sp>
+      <p:sp>
+        <p:nvSpPr>
+          <p:cNvPr id="3" name="Notes Placeholder 2"/>
+          <p:cNvSpPr>
+            <a:spLocks noGrp="1"/>
+          </p:cNvSpPr>
+          <p:nvPr>
+            <p:ph type="body" idx="1"/>
+          </p:nvPr>
+        </p:nvSpPr>
+        <p:spPr/>
+        <p:txBody>
+          <a:bodyPr/>
+          <a:lstStyle/>
+          <a:p>
+            <a:endParaRPr lang="en-US" dirty="0"/>
+          </a:p>
+        </p:txBody>
+      </p:sp>
+    </p:spTree>
+    <p:extLst>
+      <p:ext uri="{BB962C8B-B14F-4D97-AF65-F5344CB8AC3E}">
+        <p14:creationId xmlns:p14="http://schemas.microsoft.com/office/powerpoint/2010/main" val="749960313"/>
+      </p:ext>
+    </p:extLst>
+  </p:cSld>
+  <p:clrMapOvr>
+    <a:masterClrMapping/>
+  </p:clrMapOvr>
+</p:notes>
+</file>
+
 <file path=ppt/notesSlides/notesSlide2.xml><?xml version="1.0" encoding="utf-8"?>
 <p:notes xmlns:a="http://schemas.openxmlformats.org/drawingml/2006/main" xmlns:r="http://schemas.openxmlformats.org/officeDocument/2006/relationships" xmlns:p="http://schemas.openxmlformats.org/presentationml/2006/main">
   <p:cSld>
@@ -1424,6 +1628,11 @@
         </p:txBody>
       </p:sp>
     </p:spTree>
+    <p:extLst>
+      <p:ext uri="{BB962C8B-B14F-4D97-AF65-F5344CB8AC3E}">
+        <p14:creationId xmlns:p14="http://schemas.microsoft.com/office/powerpoint/2010/main" val="4162184268"/>
+      </p:ext>
+    </p:extLst>
   </p:cSld>
   <p:clrMapOvr>
     <a:masterClrMapping/>
@@ -1436,7 +1645,13 @@
   <p:cSld>
     <p:spTree>
       <p:nvGrpSpPr>
-        <p:cNvPr id="1" name="Shape 105"/>
+        <p:cNvPr id="1" name="Shape 76">
+          <a:extLst>
+            <a:ext uri="{FF2B5EF4-FFF2-40B4-BE49-F238E27FC236}">
+              <a16:creationId xmlns:a16="http://schemas.microsoft.com/office/drawing/2014/main" id="{143E44DA-4166-E0FE-C1AC-BFAA486EAC3E}"/>
+            </a:ext>
+          </a:extLst>
+        </p:cNvPr>
         <p:cNvGrpSpPr/>
         <p:nvPr/>
       </p:nvGrpSpPr>
@@ -1450,7 +1665,13 @@
       </p:grpSpPr>
       <p:sp>
         <p:nvSpPr>
-          <p:cNvPr id="106" name="Google Shape;106;g89106a2f7d_2_46:notes"/>
+          <p:cNvPr id="77" name="Google Shape;77;g89106a2f7d_2_0:notes">
+            <a:extLst>
+              <a:ext uri="{FF2B5EF4-FFF2-40B4-BE49-F238E27FC236}">
+                <a16:creationId xmlns:a16="http://schemas.microsoft.com/office/drawing/2014/main" id="{41727C43-55F7-2F42-61D8-7EBCFAAEF9A4}"/>
+              </a:ext>
+            </a:extLst>
+          </p:cNvPr>
           <p:cNvSpPr>
             <a:spLocks noGrp="1" noRot="1" noChangeAspect="1"/>
           </p:cNvSpPr>
@@ -1491,7 +1712,13 @@
       </p:sp>
       <p:sp>
         <p:nvSpPr>
-          <p:cNvPr id="107" name="Google Shape;107;g89106a2f7d_2_46:notes"/>
+          <p:cNvPr id="78" name="Google Shape;78;g89106a2f7d_2_0:notes">
+            <a:extLst>
+              <a:ext uri="{FF2B5EF4-FFF2-40B4-BE49-F238E27FC236}">
+                <a16:creationId xmlns:a16="http://schemas.microsoft.com/office/drawing/2014/main" id="{ABD3CEDB-C3E1-5813-9F26-D9739C77B989}"/>
+              </a:ext>
+            </a:extLst>
+          </p:cNvPr>
           <p:cNvSpPr txBox="1">
             <a:spLocks noGrp="1"/>
           </p:cNvSpPr>
@@ -1523,11 +1750,143 @@
               </a:spcAft>
               <a:buNone/>
             </a:pPr>
-            <a:endParaRPr/>
+            <a:endParaRPr dirty="0"/>
           </a:p>
         </p:txBody>
       </p:sp>
     </p:spTree>
+    <p:extLst>
+      <p:ext uri="{BB962C8B-B14F-4D97-AF65-F5344CB8AC3E}">
+        <p14:creationId xmlns:p14="http://schemas.microsoft.com/office/powerpoint/2010/main" val="3491594137"/>
+      </p:ext>
+    </p:extLst>
+  </p:cSld>
+  <p:clrMapOvr>
+    <a:masterClrMapping/>
+  </p:clrMapOvr>
+</p:notes>
+</file>
+
+<file path=ppt/notesSlides/notesSlide9.xml><?xml version="1.0" encoding="utf-8"?>
+<p:notes xmlns:a="http://schemas.openxmlformats.org/drawingml/2006/main" xmlns:r="http://schemas.openxmlformats.org/officeDocument/2006/relationships" xmlns:p="http://schemas.openxmlformats.org/presentationml/2006/main" showMasterSp="0" showMasterPhAnim="0">
+  <p:cSld>
+    <p:spTree>
+      <p:nvGrpSpPr>
+        <p:cNvPr id="1" name="Shape 76">
+          <a:extLst>
+            <a:ext uri="{FF2B5EF4-FFF2-40B4-BE49-F238E27FC236}">
+              <a16:creationId xmlns:a16="http://schemas.microsoft.com/office/drawing/2014/main" id="{8F00781C-E6B6-6198-643D-BB6E5E0271D0}"/>
+            </a:ext>
+          </a:extLst>
+        </p:cNvPr>
+        <p:cNvGrpSpPr/>
+        <p:nvPr/>
+      </p:nvGrpSpPr>
+      <p:grpSpPr>
+        <a:xfrm>
+          <a:off x="0" y="0"/>
+          <a:ext cx="0" cy="0"/>
+          <a:chOff x="0" y="0"/>
+          <a:chExt cx="0" cy="0"/>
+        </a:xfrm>
+      </p:grpSpPr>
+      <p:sp>
+        <p:nvSpPr>
+          <p:cNvPr id="77" name="Google Shape;77;g89106a2f7d_2_0:notes">
+            <a:extLst>
+              <a:ext uri="{FF2B5EF4-FFF2-40B4-BE49-F238E27FC236}">
+                <a16:creationId xmlns:a16="http://schemas.microsoft.com/office/drawing/2014/main" id="{140E9E1F-B3F6-A573-8D47-8A5734CE904E}"/>
+              </a:ext>
+            </a:extLst>
+          </p:cNvPr>
+          <p:cNvSpPr>
+            <a:spLocks noGrp="1" noRot="1" noChangeAspect="1"/>
+          </p:cNvSpPr>
+          <p:nvPr>
+            <p:ph type="sldImg" idx="2"/>
+          </p:nvPr>
+        </p:nvSpPr>
+        <p:spPr>
+          <a:xfrm>
+            <a:off x="1143000" y="685800"/>
+            <a:ext cx="4572000" cy="3429000"/>
+          </a:xfrm>
+          <a:custGeom>
+            <a:avLst/>
+            <a:gdLst/>
+            <a:ahLst/>
+            <a:cxnLst/>
+            <a:rect l="l" t="t" r="r" b="b"/>
+            <a:pathLst>
+              <a:path w="120000" h="120000" extrusionOk="0">
+                <a:moveTo>
+                  <a:pt x="0" y="0"/>
+                </a:moveTo>
+                <a:lnTo>
+                  <a:pt x="120000" y="0"/>
+                </a:lnTo>
+                <a:lnTo>
+                  <a:pt x="120000" y="120000"/>
+                </a:lnTo>
+                <a:lnTo>
+                  <a:pt x="0" y="120000"/>
+                </a:lnTo>
+                <a:close/>
+              </a:path>
+            </a:pathLst>
+          </a:custGeom>
+        </p:spPr>
+      </p:sp>
+      <p:sp>
+        <p:nvSpPr>
+          <p:cNvPr id="78" name="Google Shape;78;g89106a2f7d_2_0:notes">
+            <a:extLst>
+              <a:ext uri="{FF2B5EF4-FFF2-40B4-BE49-F238E27FC236}">
+                <a16:creationId xmlns:a16="http://schemas.microsoft.com/office/drawing/2014/main" id="{C45AB63B-04A2-BF61-F3D2-2D57D7E2CA15}"/>
+              </a:ext>
+            </a:extLst>
+          </p:cNvPr>
+          <p:cNvSpPr txBox="1">
+            <a:spLocks noGrp="1"/>
+          </p:cNvSpPr>
+          <p:nvPr>
+            <p:ph type="body" idx="1"/>
+          </p:nvPr>
+        </p:nvSpPr>
+        <p:spPr>
+          <a:xfrm>
+            <a:off x="685800" y="4343400"/>
+            <a:ext cx="5486400" cy="4114800"/>
+          </a:xfrm>
+          <a:prstGeom prst="rect">
+            <a:avLst/>
+          </a:prstGeom>
+        </p:spPr>
+        <p:txBody>
+          <a:bodyPr spcFirstLastPara="1" wrap="square" lIns="91425" tIns="91425" rIns="91425" bIns="91425" anchor="t" anchorCtr="0">
+            <a:noAutofit/>
+          </a:bodyPr>
+          <a:lstStyle/>
+          <a:p>
+            <a:pPr marL="0" lvl="0" indent="0" algn="l" rtl="0">
+              <a:spcBef>
+                <a:spcPts val="0"/>
+              </a:spcBef>
+              <a:spcAft>
+                <a:spcPts val="0"/>
+              </a:spcAft>
+              <a:buNone/>
+            </a:pPr>
+            <a:endParaRPr dirty="0"/>
+          </a:p>
+        </p:txBody>
+      </p:sp>
+    </p:spTree>
+    <p:extLst>
+      <p:ext uri="{BB962C8B-B14F-4D97-AF65-F5344CB8AC3E}">
+        <p14:creationId xmlns:p14="http://schemas.microsoft.com/office/powerpoint/2010/main" val="2412810740"/>
+      </p:ext>
+    </p:extLst>
   </p:cSld>
   <p:clrMapOvr>
     <a:masterClrMapping/>
@@ -11113,136 +11472,6 @@
           <p:cNvPr id="2" name="Title 1">
             <a:extLst>
               <a:ext uri="{FF2B5EF4-FFF2-40B4-BE49-F238E27FC236}">
-                <a16:creationId xmlns:a16="http://schemas.microsoft.com/office/drawing/2014/main" id="{5E912C88-7968-0C49-2122-4BD5988A61D0}"/>
-              </a:ext>
-            </a:extLst>
-          </p:cNvPr>
-          <p:cNvSpPr>
-            <a:spLocks noGrp="1"/>
-          </p:cNvSpPr>
-          <p:nvPr>
-            <p:ph type="title"/>
-          </p:nvPr>
-        </p:nvSpPr>
-        <p:spPr/>
-        <p:txBody>
-          <a:bodyPr>
-            <a:normAutofit fontScale="90000"/>
-          </a:bodyPr>
-          <a:lstStyle/>
-          <a:p>
-            <a:endParaRPr lang="en-US"/>
-          </a:p>
-        </p:txBody>
-      </p:sp>
-      <p:sp>
-        <p:nvSpPr>
-          <p:cNvPr id="3" name="Text Placeholder 2">
-            <a:extLst>
-              <a:ext uri="{FF2B5EF4-FFF2-40B4-BE49-F238E27FC236}">
-                <a16:creationId xmlns:a16="http://schemas.microsoft.com/office/drawing/2014/main" id="{10B538AC-6CAE-4D52-C6E9-51DE03A90500}"/>
-              </a:ext>
-            </a:extLst>
-          </p:cNvPr>
-          <p:cNvSpPr>
-            <a:spLocks noGrp="1"/>
-          </p:cNvSpPr>
-          <p:nvPr>
-            <p:ph type="body" idx="1"/>
-          </p:nvPr>
-        </p:nvSpPr>
-        <p:spPr/>
-        <p:txBody>
-          <a:bodyPr>
-            <a:normAutofit fontScale="92500" lnSpcReduction="10000"/>
-          </a:bodyPr>
-          <a:lstStyle/>
-          <a:p>
-            <a:r>
-              <a:rPr lang="en-GB" dirty="0">
-                <a:hlinkClick r:id="rId2" tooltip="View other papers by this author"/>
-              </a:rPr>
-              <a:t>David Stromberg</a:t>
-            </a:r>
-            <a:endParaRPr lang="en-GB" dirty="0"/>
-          </a:p>
-          <a:p>
-            <a:r>
-              <a:rPr lang="en-GB" dirty="0"/>
-              <a:t>Stockholm University</a:t>
-            </a:r>
-          </a:p>
-          <a:p>
-            <a:r>
-              <a:rPr lang="en-GB" dirty="0">
-                <a:hlinkClick r:id="rId3" tooltip="View other papers by this author"/>
-              </a:rPr>
-              <a:t>Victor Lei</a:t>
-            </a:r>
-            <a:endParaRPr lang="en-GB" dirty="0"/>
-          </a:p>
-          <a:p>
-            <a:r>
-              <a:rPr lang="en-GB" dirty="0"/>
-              <a:t>The University of Hong Kong - University of Hong Kong</a:t>
-            </a:r>
-          </a:p>
-          <a:p>
-            <a:r>
-              <a:rPr lang="en-GB" dirty="0">
-                <a:hlinkClick r:id="rId4" tooltip="View other papers by this author"/>
-              </a:rPr>
-              <a:t>Yanhui Wu</a:t>
-            </a:r>
-            <a:endParaRPr lang="en-GB" dirty="0"/>
-          </a:p>
-          <a:p>
-            <a:r>
-              <a:rPr lang="en-GB" dirty="0"/>
-              <a:t>University of Hong Kong; Centre for Economic Policy Research (CEPR)</a:t>
-            </a:r>
-          </a:p>
-          <a:p>
-            <a:endParaRPr lang="en-US" dirty="0"/>
-          </a:p>
-        </p:txBody>
-      </p:sp>
-    </p:spTree>
-    <p:extLst>
-      <p:ext uri="{BB962C8B-B14F-4D97-AF65-F5344CB8AC3E}">
-        <p14:creationId xmlns:p14="http://schemas.microsoft.com/office/powerpoint/2010/main" val="326419308"/>
-      </p:ext>
-    </p:extLst>
-  </p:cSld>
-  <p:clrMapOvr>
-    <a:masterClrMapping/>
-  </p:clrMapOvr>
-  <p:transition spd="med"/>
-</p:sld>
-</file>
-
-<file path=ppt/slides/slide11.xml><?xml version="1.0" encoding="utf-8"?>
-<p:sld xmlns:a="http://schemas.openxmlformats.org/drawingml/2006/main" xmlns:r="http://schemas.openxmlformats.org/officeDocument/2006/relationships" xmlns:p="http://schemas.openxmlformats.org/presentationml/2006/main">
-  <p:cSld>
-    <p:spTree>
-      <p:nvGrpSpPr>
-        <p:cNvPr id="1" name=""/>
-        <p:cNvGrpSpPr/>
-        <p:nvPr/>
-      </p:nvGrpSpPr>
-      <p:grpSpPr>
-        <a:xfrm>
-          <a:off x="0" y="0"/>
-          <a:ext cx="0" cy="0"/>
-          <a:chOff x="0" y="0"/>
-          <a:chExt cx="0" cy="0"/>
-        </a:xfrm>
-      </p:grpSpPr>
-      <p:sp>
-        <p:nvSpPr>
-          <p:cNvPr id="2" name="Title 1">
-            <a:extLst>
-              <a:ext uri="{FF2B5EF4-FFF2-40B4-BE49-F238E27FC236}">
                 <a16:creationId xmlns:a16="http://schemas.microsoft.com/office/drawing/2014/main" id="{010C42F7-CB0E-66EF-26C3-A9D640ECE7E4}"/>
               </a:ext>
             </a:extLst>
@@ -11332,7 +11561,7 @@
 </p:sld>
 </file>
 
-<file path=ppt/slides/slide12.xml><?xml version="1.0" encoding="utf-8"?>
+<file path=ppt/slides/slide11.xml><?xml version="1.0" encoding="utf-8"?>
 <p:sld xmlns:a="http://schemas.openxmlformats.org/drawingml/2006/main" xmlns:r="http://schemas.openxmlformats.org/officeDocument/2006/relationships" xmlns:p="http://schemas.openxmlformats.org/presentationml/2006/main">
   <p:cSld>
     <p:spTree>
@@ -11453,7 +11682,7 @@
 </p:sld>
 </file>
 
-<file path=ppt/slides/slide13.xml><?xml version="1.0" encoding="utf-8"?>
+<file path=ppt/slides/slide12.xml><?xml version="1.0" encoding="utf-8"?>
 <p:sld xmlns:a="http://schemas.openxmlformats.org/drawingml/2006/main" xmlns:r="http://schemas.openxmlformats.org/officeDocument/2006/relationships" xmlns:p="http://schemas.openxmlformats.org/presentationml/2006/main">
   <p:cSld>
     <p:spTree>
@@ -11544,7 +11773,7 @@
 </p:sld>
 </file>
 
-<file path=ppt/slides/slide14.xml><?xml version="1.0" encoding="utf-8"?>
+<file path=ppt/slides/slide13.xml><?xml version="1.0" encoding="utf-8"?>
 <p:sld xmlns:a="http://schemas.openxmlformats.org/drawingml/2006/main" xmlns:r="http://schemas.openxmlformats.org/officeDocument/2006/relationships" xmlns:p="http://schemas.openxmlformats.org/presentationml/2006/main">
   <p:cSld>
     <p:spTree>
@@ -11692,7 +11921,7 @@
 </p:sld>
 </file>
 
-<file path=ppt/slides/slide15.xml><?xml version="1.0" encoding="utf-8"?>
+<file path=ppt/slides/slide14.xml><?xml version="1.0" encoding="utf-8"?>
 <p:sld xmlns:a="http://schemas.openxmlformats.org/drawingml/2006/main" xmlns:r="http://schemas.openxmlformats.org/officeDocument/2006/relationships" xmlns:p="http://schemas.openxmlformats.org/presentationml/2006/main">
   <p:cSld>
     <p:spTree>
@@ -11753,7 +11982,7 @@
 </p:sld>
 </file>
 
-<file path=ppt/slides/slide16.xml><?xml version="1.0" encoding="utf-8"?>
+<file path=ppt/slides/slide15.xml><?xml version="1.0" encoding="utf-8"?>
 <p:sld xmlns:a="http://schemas.openxmlformats.org/drawingml/2006/main" xmlns:r="http://schemas.openxmlformats.org/officeDocument/2006/relationships" xmlns:p="http://schemas.openxmlformats.org/presentationml/2006/main" show="0">
   <p:cSld>
     <p:spTree>
@@ -12171,7 +12400,7 @@
 </p:sld>
 </file>
 
-<file path=ppt/slides/slide17.xml><?xml version="1.0" encoding="utf-8"?>
+<file path=ppt/slides/slide16.xml><?xml version="1.0" encoding="utf-8"?>
 <p:sld xmlns:a="http://schemas.openxmlformats.org/drawingml/2006/main" xmlns:r="http://schemas.openxmlformats.org/officeDocument/2006/relationships" xmlns:p="http://schemas.openxmlformats.org/presentationml/2006/main" show="0">
   <p:cSld>
     <p:spTree>
@@ -12320,7 +12549,7 @@
 </p:sld>
 </file>
 
-<file path=ppt/slides/slide18.xml><?xml version="1.0" encoding="utf-8"?>
+<file path=ppt/slides/slide17.xml><?xml version="1.0" encoding="utf-8"?>
 <p:sld xmlns:a="http://schemas.openxmlformats.org/drawingml/2006/main" xmlns:r="http://schemas.openxmlformats.org/officeDocument/2006/relationships" xmlns:p="http://schemas.openxmlformats.org/presentationml/2006/main" show="0">
   <p:cSld>
     <p:spTree>
@@ -12764,441 +12993,7 @@
 </p:sld>
 </file>
 
-<file path=ppt/slides/slide19.xml><?xml version="1.0" encoding="utf-8"?>
-<p:sld xmlns:a="http://schemas.openxmlformats.org/drawingml/2006/main" xmlns:r="http://schemas.openxmlformats.org/officeDocument/2006/relationships" xmlns:p="http://schemas.openxmlformats.org/presentationml/2006/main">
-  <p:cSld>
-    <p:spTree>
-      <p:nvGrpSpPr>
-        <p:cNvPr id="1" name="Shape 79"/>
-        <p:cNvGrpSpPr/>
-        <p:nvPr/>
-      </p:nvGrpSpPr>
-      <p:grpSpPr>
-        <a:xfrm>
-          <a:off x="0" y="0"/>
-          <a:ext cx="0" cy="0"/>
-          <a:chOff x="0" y="0"/>
-          <a:chExt cx="0" cy="0"/>
-        </a:xfrm>
-      </p:grpSpPr>
-      <p:sp>
-        <p:nvSpPr>
-          <p:cNvPr id="80" name="Google Shape;80;p16"/>
-          <p:cNvSpPr txBox="1">
-            <a:spLocks noGrp="1"/>
-          </p:cNvSpPr>
-          <p:nvPr>
-            <p:ph type="title"/>
-          </p:nvPr>
-        </p:nvSpPr>
-        <p:spPr>
-          <a:xfrm>
-            <a:off x="443307" y="1852124"/>
-            <a:ext cx="12118187" cy="814507"/>
-          </a:xfrm>
-          <a:prstGeom prst="rect">
-            <a:avLst/>
-          </a:prstGeom>
-        </p:spPr>
-        <p:txBody>
-          <a:bodyPr spcFirstLastPara="1" wrap="square" lIns="130027" tIns="130027" rIns="130027" bIns="130027" anchor="t" anchorCtr="0">
-            <a:noAutofit/>
-          </a:bodyPr>
-          <a:lstStyle/>
-          <a:p>
-            <a:r>
-              <a:rPr lang="en"/>
-              <a:t>Data Science Lifecycle</a:t>
-            </a:r>
-            <a:endParaRPr/>
-          </a:p>
-        </p:txBody>
-      </p:sp>
-      <p:pic>
-        <p:nvPicPr>
-          <p:cNvPr id="81" name="Google Shape;81;p16"/>
-          <p:cNvPicPr preferRelativeResize="0"/>
-          <p:nvPr/>
-        </p:nvPicPr>
-        <p:blipFill>
-          <a:blip r:embed="rId3">
-            <a:alphaModFix/>
-          </a:blip>
-          <a:stretch>
-            <a:fillRect/>
-          </a:stretch>
-        </p:blipFill>
-        <p:spPr>
-          <a:xfrm>
-            <a:off x="3151111" y="2666632"/>
-            <a:ext cx="6702566" cy="5434276"/>
-          </a:xfrm>
-          <a:prstGeom prst="rect">
-            <a:avLst/>
-          </a:prstGeom>
-          <a:noFill/>
-          <a:ln>
-            <a:noFill/>
-          </a:ln>
-        </p:spPr>
-      </p:pic>
-      <p:sp>
-        <p:nvSpPr>
-          <p:cNvPr id="82" name="Google Shape;82;p16"/>
-          <p:cNvSpPr txBox="1"/>
-          <p:nvPr/>
-        </p:nvSpPr>
-        <p:spPr>
-          <a:xfrm>
-            <a:off x="8785920" y="7936889"/>
-            <a:ext cx="4218880" cy="506880"/>
-          </a:xfrm>
-          <a:prstGeom prst="rect">
-            <a:avLst/>
-          </a:prstGeom>
-          <a:noFill/>
-          <a:ln>
-            <a:noFill/>
-          </a:ln>
-        </p:spPr>
-        <p:txBody>
-          <a:bodyPr spcFirstLastPara="1" wrap="square" lIns="130027" tIns="130027" rIns="130027" bIns="130027" anchor="t" anchorCtr="0">
-            <a:noAutofit/>
-          </a:bodyPr>
-          <a:lstStyle/>
-          <a:p>
-            <a:pPr algn="l" defTabSz="1300460" hangingPunct="1">
-              <a:buClr>
-                <a:srgbClr val="000000"/>
-              </a:buClr>
-            </a:pPr>
-            <a:r>
-              <a:rPr lang="en" sz="1849" i="1">
-                <a:latin typeface="Arial"/>
-                <a:cs typeface="Arial"/>
-                <a:sym typeface="Arial"/>
-              </a:rPr>
-              <a:t>Source: Data 100 Spring 2020 Slides</a:t>
-            </a:r>
-            <a:endParaRPr sz="1849" i="1">
-              <a:latin typeface="Arial"/>
-              <a:cs typeface="Arial"/>
-              <a:sym typeface="Arial"/>
-            </a:endParaRPr>
-          </a:p>
-        </p:txBody>
-      </p:sp>
-    </p:spTree>
-  </p:cSld>
-  <p:clrMapOvr>
-    <a:masterClrMapping/>
-  </p:clrMapOvr>
-</p:sld>
-</file>
-
-<file path=ppt/slides/slide2.xml><?xml version="1.0" encoding="utf-8"?>
-<p:sld xmlns:a="http://schemas.openxmlformats.org/drawingml/2006/main" xmlns:r="http://schemas.openxmlformats.org/officeDocument/2006/relationships" xmlns:p="http://schemas.openxmlformats.org/presentationml/2006/main">
-  <p:cSld>
-    <p:spTree>
-      <p:nvGrpSpPr>
-        <p:cNvPr id="1" name=""/>
-        <p:cNvGrpSpPr/>
-        <p:nvPr/>
-      </p:nvGrpSpPr>
-      <p:grpSpPr>
-        <a:xfrm>
-          <a:off x="0" y="0"/>
-          <a:ext cx="0" cy="0"/>
-          <a:chOff x="0" y="0"/>
-          <a:chExt cx="0" cy="0"/>
-        </a:xfrm>
-      </p:grpSpPr>
-      <p:sp>
-        <p:nvSpPr>
-          <p:cNvPr id="2" name="Title 1">
-            <a:extLst>
-              <a:ext uri="{FF2B5EF4-FFF2-40B4-BE49-F238E27FC236}">
-                <a16:creationId xmlns:a16="http://schemas.microsoft.com/office/drawing/2014/main" id="{B4DFD8B1-4986-D247-A278-F0C7DD87E156}"/>
-              </a:ext>
-            </a:extLst>
-          </p:cNvPr>
-          <p:cNvSpPr>
-            <a:spLocks noGrp="1"/>
-          </p:cNvSpPr>
-          <p:nvPr>
-            <p:ph type="title"/>
-          </p:nvPr>
-        </p:nvSpPr>
-        <p:spPr/>
-        <p:txBody>
-          <a:bodyPr>
-            <a:normAutofit/>
-          </a:bodyPr>
-          <a:lstStyle/>
-          <a:p>
-            <a:r>
-              <a:rPr lang="en-US" dirty="0"/>
-              <a:t>About</a:t>
-            </a:r>
-          </a:p>
-        </p:txBody>
-      </p:sp>
-    </p:spTree>
-    <p:extLst>
-      <p:ext uri="{BB962C8B-B14F-4D97-AF65-F5344CB8AC3E}">
-        <p14:creationId xmlns:p14="http://schemas.microsoft.com/office/powerpoint/2010/main" val="2375518132"/>
-      </p:ext>
-    </p:extLst>
-  </p:cSld>
-  <p:clrMapOvr>
-    <a:masterClrMapping/>
-  </p:clrMapOvr>
-  <p:transition spd="med"/>
-</p:sld>
-</file>
-
-<file path=ppt/slides/slide20.xml><?xml version="1.0" encoding="utf-8"?>
-<p:sld xmlns:a="http://schemas.openxmlformats.org/drawingml/2006/main" xmlns:r="http://schemas.openxmlformats.org/officeDocument/2006/relationships" xmlns:p="http://schemas.openxmlformats.org/presentationml/2006/main">
-  <p:cSld>
-    <p:spTree>
-      <p:nvGrpSpPr>
-        <p:cNvPr id="1" name="Shape 108"/>
-        <p:cNvGrpSpPr/>
-        <p:nvPr/>
-      </p:nvGrpSpPr>
-      <p:grpSpPr>
-        <a:xfrm>
-          <a:off x="0" y="0"/>
-          <a:ext cx="0" cy="0"/>
-          <a:chOff x="0" y="0"/>
-          <a:chExt cx="0" cy="0"/>
-        </a:xfrm>
-      </p:grpSpPr>
-      <p:pic>
-        <p:nvPicPr>
-          <p:cNvPr id="111" name="Google Shape;111;p20"/>
-          <p:cNvPicPr preferRelativeResize="0"/>
-          <p:nvPr/>
-        </p:nvPicPr>
-        <p:blipFill>
-          <a:blip r:embed="rId3">
-            <a:alphaModFix/>
-          </a:blip>
-          <a:stretch>
-            <a:fillRect/>
-          </a:stretch>
-        </p:blipFill>
-        <p:spPr>
-          <a:xfrm>
-            <a:off x="872284" y="5480017"/>
-            <a:ext cx="4123486" cy="1666560"/>
-          </a:xfrm>
-          <a:prstGeom prst="rect">
-            <a:avLst/>
-          </a:prstGeom>
-          <a:noFill/>
-          <a:ln>
-            <a:noFill/>
-          </a:ln>
-        </p:spPr>
-      </p:pic>
-      <p:pic>
-        <p:nvPicPr>
-          <p:cNvPr id="112" name="Google Shape;112;p20"/>
-          <p:cNvPicPr preferRelativeResize="0"/>
-          <p:nvPr/>
-        </p:nvPicPr>
-        <p:blipFill>
-          <a:blip r:embed="rId4">
-            <a:alphaModFix/>
-          </a:blip>
-          <a:stretch>
-            <a:fillRect/>
-          </a:stretch>
-        </p:blipFill>
-        <p:spPr>
-          <a:xfrm>
-            <a:off x="7612551" y="5697351"/>
-            <a:ext cx="4123486" cy="989619"/>
-          </a:xfrm>
-          <a:prstGeom prst="rect">
-            <a:avLst/>
-          </a:prstGeom>
-          <a:noFill/>
-          <a:ln>
-            <a:noFill/>
-          </a:ln>
-        </p:spPr>
-      </p:pic>
-      <p:pic>
-        <p:nvPicPr>
-          <p:cNvPr id="113" name="Google Shape;113;p20"/>
-          <p:cNvPicPr preferRelativeResize="0"/>
-          <p:nvPr/>
-        </p:nvPicPr>
-        <p:blipFill>
-          <a:blip r:embed="rId5">
-            <a:alphaModFix/>
-          </a:blip>
-          <a:stretch>
-            <a:fillRect/>
-          </a:stretch>
-        </p:blipFill>
-        <p:spPr>
-          <a:xfrm>
-            <a:off x="1891840" y="7095634"/>
-            <a:ext cx="4210223" cy="1666560"/>
-          </a:xfrm>
-          <a:prstGeom prst="rect">
-            <a:avLst/>
-          </a:prstGeom>
-          <a:noFill/>
-          <a:ln>
-            <a:noFill/>
-          </a:ln>
-        </p:spPr>
-      </p:pic>
-      <p:pic>
-        <p:nvPicPr>
-          <p:cNvPr id="7" name="Google Shape;149;p24">
-            <a:extLst>
-              <a:ext uri="{FF2B5EF4-FFF2-40B4-BE49-F238E27FC236}">
-                <a16:creationId xmlns:a16="http://schemas.microsoft.com/office/drawing/2014/main" id="{4229D4BB-3421-C541-9044-CD553696EE8B}"/>
-              </a:ext>
-            </a:extLst>
-          </p:cNvPr>
-          <p:cNvPicPr preferRelativeResize="0"/>
-          <p:nvPr/>
-        </p:nvPicPr>
-        <p:blipFill>
-          <a:blip r:embed="rId6">
-            <a:alphaModFix/>
-          </a:blip>
-          <a:stretch>
-            <a:fillRect/>
-          </a:stretch>
-        </p:blipFill>
-        <p:spPr>
-          <a:xfrm>
-            <a:off x="7121619" y="6808482"/>
-            <a:ext cx="3733120" cy="2009636"/>
-          </a:xfrm>
-          <a:prstGeom prst="rect">
-            <a:avLst/>
-          </a:prstGeom>
-          <a:noFill/>
-          <a:ln>
-            <a:noFill/>
-          </a:ln>
-        </p:spPr>
-      </p:pic>
-      <p:pic>
-        <p:nvPicPr>
-          <p:cNvPr id="8" name="Google Shape;104;p19">
-            <a:extLst>
-              <a:ext uri="{FF2B5EF4-FFF2-40B4-BE49-F238E27FC236}">
-                <a16:creationId xmlns:a16="http://schemas.microsoft.com/office/drawing/2014/main" id="{2B095501-45B8-4A43-BBBA-0F407C59476D}"/>
-              </a:ext>
-            </a:extLst>
-          </p:cNvPr>
-          <p:cNvPicPr preferRelativeResize="0"/>
-          <p:nvPr/>
-        </p:nvPicPr>
-        <p:blipFill>
-          <a:blip r:embed="rId7">
-            <a:alphaModFix/>
-          </a:blip>
-          <a:stretch>
-            <a:fillRect/>
-          </a:stretch>
-        </p:blipFill>
-        <p:spPr>
-          <a:xfrm>
-            <a:off x="2447468" y="2248622"/>
-            <a:ext cx="3098966" cy="2772256"/>
-          </a:xfrm>
-          <a:prstGeom prst="rect">
-            <a:avLst/>
-          </a:prstGeom>
-          <a:noFill/>
-          <a:ln>
-            <a:noFill/>
-          </a:ln>
-        </p:spPr>
-      </p:pic>
-      <p:sp>
-        <p:nvSpPr>
-          <p:cNvPr id="5" name="Title 4">
-            <a:extLst>
-              <a:ext uri="{FF2B5EF4-FFF2-40B4-BE49-F238E27FC236}">
-                <a16:creationId xmlns:a16="http://schemas.microsoft.com/office/drawing/2014/main" id="{B9DFAE89-562C-5B42-AA09-0CD353D17B43}"/>
-              </a:ext>
-            </a:extLst>
-          </p:cNvPr>
-          <p:cNvSpPr>
-            <a:spLocks noGrp="1"/>
-          </p:cNvSpPr>
-          <p:nvPr>
-            <p:ph type="title"/>
-          </p:nvPr>
-        </p:nvSpPr>
-        <p:spPr/>
-        <p:txBody>
-          <a:bodyPr/>
-          <a:lstStyle/>
-          <a:p>
-            <a:endParaRPr lang="en-US"/>
-          </a:p>
-        </p:txBody>
-      </p:sp>
-      <p:pic>
-        <p:nvPicPr>
-          <p:cNvPr id="9" name="Graphic 8">
-            <a:extLst>
-              <a:ext uri="{FF2B5EF4-FFF2-40B4-BE49-F238E27FC236}">
-                <a16:creationId xmlns:a16="http://schemas.microsoft.com/office/drawing/2014/main" id="{527A662C-357B-E142-B95C-07159A0A6D18}"/>
-              </a:ext>
-            </a:extLst>
-          </p:cNvPr>
-          <p:cNvPicPr>
-            <a:picLocks noChangeAspect="1"/>
-          </p:cNvPicPr>
-          <p:nvPr/>
-        </p:nvPicPr>
-        <p:blipFill>
-          <a:blip>
-            <a:extLst>
-              <a:ext uri="{28A0092B-C50C-407E-A947-70E740481C1C}">
-                <a14:useLocalDpi xmlns:a14="http://schemas.microsoft.com/office/drawing/2010/main" val="0"/>
-              </a:ext>
-              <a:ext uri="{96DAC541-7B7A-43D3-8B79-37D633B846F1}">
-                <asvg:svgBlip xmlns:asvg="http://schemas.microsoft.com/office/drawing/2016/SVG/main" r:embed="rId8"/>
-              </a:ext>
-            </a:extLst>
-          </a:blip>
-          <a:stretch>
-            <a:fillRect/>
-          </a:stretch>
-        </p:blipFill>
-        <p:spPr>
-          <a:xfrm>
-            <a:off x="7418398" y="2248622"/>
-            <a:ext cx="2806212" cy="3231395"/>
-          </a:xfrm>
-          <a:prstGeom prst="rect">
-            <a:avLst/>
-          </a:prstGeom>
-        </p:spPr>
-      </p:pic>
-    </p:spTree>
-  </p:cSld>
-  <p:clrMapOvr>
-    <a:masterClrMapping/>
-  </p:clrMapOvr>
-</p:sld>
-</file>
-
-<file path=ppt/slides/slide21.xml><?xml version="1.0" encoding="utf-8"?>
+<file path=ppt/slides/slide18.xml><?xml version="1.0" encoding="utf-8"?>
 <p:sld xmlns:a="http://schemas.openxmlformats.org/drawingml/2006/main" xmlns:r="http://schemas.openxmlformats.org/officeDocument/2006/relationships" xmlns:p="http://schemas.openxmlformats.org/presentationml/2006/main">
   <p:cSld>
     <p:spTree>
@@ -13258,7 +13053,7 @@
 </p:sld>
 </file>
 
-<file path=ppt/slides/slide22.xml><?xml version="1.0" encoding="utf-8"?>
+<file path=ppt/slides/slide19.xml><?xml version="1.0" encoding="utf-8"?>
 <p:sld xmlns:a="http://schemas.openxmlformats.org/drawingml/2006/main" xmlns:r="http://schemas.openxmlformats.org/officeDocument/2006/relationships" xmlns:p="http://schemas.openxmlformats.org/presentationml/2006/main">
   <p:cSld>
     <p:spTree>
@@ -13359,7 +13154,7 @@
           <a:p>
             <a:fld id="{86CB4B4D-7CA3-9044-876B-883B54F8677D}" type="slidenum">
               <a:rPr/>
-              <a:t>22</a:t>
+              <a:t>19</a:t>
             </a:fld>
             <a:endParaRPr/>
           </a:p>
@@ -13579,7 +13374,117 @@
 </p:sld>
 </file>
 
-<file path=ppt/slides/slide23.xml><?xml version="1.0" encoding="utf-8"?>
+<file path=ppt/slides/slide2.xml><?xml version="1.0" encoding="utf-8"?>
+<p:sld xmlns:a="http://schemas.openxmlformats.org/drawingml/2006/main" xmlns:r="http://schemas.openxmlformats.org/officeDocument/2006/relationships" xmlns:p="http://schemas.openxmlformats.org/presentationml/2006/main">
+  <p:cSld>
+    <p:spTree>
+      <p:nvGrpSpPr>
+        <p:cNvPr id="1" name=""/>
+        <p:cNvGrpSpPr/>
+        <p:nvPr/>
+      </p:nvGrpSpPr>
+      <p:grpSpPr>
+        <a:xfrm>
+          <a:off x="0" y="0"/>
+          <a:ext cx="0" cy="0"/>
+          <a:chOff x="0" y="0"/>
+          <a:chExt cx="0" cy="0"/>
+        </a:xfrm>
+      </p:grpSpPr>
+      <p:sp>
+        <p:nvSpPr>
+          <p:cNvPr id="9" name="Title 8">
+            <a:extLst>
+              <a:ext uri="{FF2B5EF4-FFF2-40B4-BE49-F238E27FC236}">
+                <a16:creationId xmlns:a16="http://schemas.microsoft.com/office/drawing/2014/main" id="{7FE4D6C6-66B8-9044-AC75-FA288B4AA0C5}"/>
+              </a:ext>
+            </a:extLst>
+          </p:cNvPr>
+          <p:cNvSpPr>
+            <a:spLocks noGrp="1"/>
+          </p:cNvSpPr>
+          <p:nvPr>
+            <p:ph type="title"/>
+          </p:nvPr>
+        </p:nvSpPr>
+        <p:spPr/>
+        <p:txBody>
+          <a:bodyPr>
+            <a:normAutofit fontScale="90000"/>
+          </a:bodyPr>
+          <a:lstStyle/>
+          <a:p>
+            <a:r>
+              <a:rPr lang="en-US" dirty="0"/>
+              <a:t>Assessments</a:t>
+            </a:r>
+          </a:p>
+        </p:txBody>
+      </p:sp>
+      <p:sp>
+        <p:nvSpPr>
+          <p:cNvPr id="10" name="Text Placeholder 9">
+            <a:extLst>
+              <a:ext uri="{FF2B5EF4-FFF2-40B4-BE49-F238E27FC236}">
+                <a16:creationId xmlns:a16="http://schemas.microsoft.com/office/drawing/2014/main" id="{F65DCA9F-D82A-9C43-8E1D-AFD3DF9E2401}"/>
+              </a:ext>
+            </a:extLst>
+          </p:cNvPr>
+          <p:cNvSpPr>
+            <a:spLocks noGrp="1"/>
+          </p:cNvSpPr>
+          <p:nvPr>
+            <p:ph type="body" idx="1"/>
+          </p:nvPr>
+        </p:nvSpPr>
+        <p:spPr/>
+        <p:txBody>
+          <a:bodyPr/>
+          <a:lstStyle/>
+          <a:p>
+            <a:r>
+              <a:rPr lang="en-US" dirty="0"/>
+              <a:t>2 assessments. </a:t>
+            </a:r>
+          </a:p>
+          <a:p>
+            <a:r>
+              <a:rPr lang="en-GB" dirty="0"/>
+              <a:t>Programming </a:t>
+            </a:r>
+            <a:r>
+              <a:rPr lang="en-GB" dirty="0" err="1"/>
+              <a:t>excercise</a:t>
+            </a:r>
+            <a:r>
+              <a:rPr lang="en-GB" dirty="0"/>
+              <a:t>: 25% due Thursday 1pm, week 7</a:t>
+            </a:r>
+          </a:p>
+          <a:p>
+            <a:r>
+              <a:rPr lang="en-GB" dirty="0"/>
+              <a:t>Final Project: 75%, Thursday, 1pm,  week 11 </a:t>
+            </a:r>
+            <a:endParaRPr lang="en-US" dirty="0"/>
+          </a:p>
+        </p:txBody>
+      </p:sp>
+    </p:spTree>
+    <p:extLst>
+      <p:ext uri="{BB962C8B-B14F-4D97-AF65-F5344CB8AC3E}">
+        <p14:creationId xmlns:p14="http://schemas.microsoft.com/office/powerpoint/2010/main" val="1917384157"/>
+      </p:ext>
+    </p:extLst>
+  </p:cSld>
+  <p:clrMapOvr>
+    <a:masterClrMapping/>
+  </p:clrMapOvr>
+  <p:transition spd="med"/>
+</p:sld>
+</file>
+
+<file path=ppt/slides/slide20.xml><?xml version="1.0" encoding="utf-8"?>
 <p:sld xmlns:a="http://schemas.openxmlformats.org/drawingml/2006/main" xmlns:r="http://schemas.openxmlformats.org/officeDocument/2006/relationships" xmlns:p="http://schemas.openxmlformats.org/presentationml/2006/main">
   <p:cSld>
     <p:spTree>
@@ -14439,7 +14344,7 @@
 </p:sld>
 </file>
 
-<file path=ppt/slides/slide24.xml><?xml version="1.0" encoding="utf-8"?>
+<file path=ppt/slides/slide21.xml><?xml version="1.0" encoding="utf-8"?>
 <p:sld xmlns:a="http://schemas.openxmlformats.org/drawingml/2006/main" xmlns:r="http://schemas.openxmlformats.org/officeDocument/2006/relationships" xmlns:p="http://schemas.openxmlformats.org/presentationml/2006/main">
   <p:cSld>
     <p:spTree>
@@ -14713,7 +14618,7 @@
 </p:sld>
 </file>
 
-<file path=ppt/slides/slide25.xml><?xml version="1.0" encoding="utf-8"?>
+<file path=ppt/slides/slide22.xml><?xml version="1.0" encoding="utf-8"?>
 <p:sld xmlns:a="http://schemas.openxmlformats.org/drawingml/2006/main" xmlns:r="http://schemas.openxmlformats.org/officeDocument/2006/relationships" xmlns:p="http://schemas.openxmlformats.org/presentationml/2006/main">
   <p:cSld>
     <p:spTree>
@@ -14823,7 +14728,7 @@
           <a:p>
             <a:fld id="{86CB4B4D-7CA3-9044-876B-883B54F8677D}" type="slidenum">
               <a:rPr/>
-              <a:t>25</a:t>
+              <a:t>22</a:t>
             </a:fld>
             <a:endParaRPr/>
           </a:p>
@@ -14838,7 +14743,7 @@
 </p:sld>
 </file>
 
-<file path=ppt/slides/slide26.xml><?xml version="1.0" encoding="utf-8"?>
+<file path=ppt/slides/slide23.xml><?xml version="1.0" encoding="utf-8"?>
 <p:sld xmlns:a="http://schemas.openxmlformats.org/drawingml/2006/main" xmlns:r="http://schemas.openxmlformats.org/officeDocument/2006/relationships" xmlns:p="http://schemas.openxmlformats.org/presentationml/2006/main">
   <p:cSld>
     <p:spTree>
@@ -14902,7 +14807,7 @@
         <p:spPr>
           <a:xfrm>
             <a:off x="650239" y="2156090"/>
-            <a:ext cx="11704322" cy="8543395"/>
+            <a:ext cx="11704322" cy="5638081"/>
           </a:xfrm>
           <a:prstGeom prst="rect">
             <a:avLst/>
@@ -14976,7 +14881,7 @@
           <a:p>
             <a:fld id="{86CB4B4D-7CA3-9044-876B-883B54F8677D}" type="slidenum">
               <a:rPr/>
-              <a:t>26</a:t>
+              <a:t>23</a:t>
             </a:fld>
             <a:endParaRPr/>
           </a:p>
@@ -15214,7 +15119,7 @@
 </p:sld>
 </file>
 
-<file path=ppt/slides/slide27.xml><?xml version="1.0" encoding="utf-8"?>
+<file path=ppt/slides/slide24.xml><?xml version="1.0" encoding="utf-8"?>
 <p:sld xmlns:a="http://schemas.openxmlformats.org/drawingml/2006/main" xmlns:r="http://schemas.openxmlformats.org/officeDocument/2006/relationships" xmlns:p="http://schemas.openxmlformats.org/presentationml/2006/main">
   <p:cSld>
     <p:spTree>
@@ -15262,43 +15167,1050 @@
           </a:p>
         </p:txBody>
       </p:sp>
+    </p:spTree>
+  </p:cSld>
+  <p:clrMapOvr>
+    <a:masterClrMapping/>
+  </p:clrMapOvr>
+  <p:transition spd="med"/>
+</p:sld>
+</file>
+
+<file path=ppt/slides/slide25.xml><?xml version="1.0" encoding="utf-8"?>
+<p:sld xmlns:a="http://schemas.openxmlformats.org/drawingml/2006/main" xmlns:r="http://schemas.openxmlformats.org/officeDocument/2006/relationships" xmlns:p="http://schemas.openxmlformats.org/presentationml/2006/main">
+  <p:cSld>
+    <p:spTree>
+      <p:nvGrpSpPr>
+        <p:cNvPr id="1" name="Shape 79"/>
+        <p:cNvGrpSpPr/>
+        <p:nvPr/>
+      </p:nvGrpSpPr>
+      <p:grpSpPr>
+        <a:xfrm>
+          <a:off x="0" y="0"/>
+          <a:ext cx="0" cy="0"/>
+          <a:chOff x="0" y="0"/>
+          <a:chExt cx="0" cy="0"/>
+        </a:xfrm>
+      </p:grpSpPr>
       <p:sp>
         <p:nvSpPr>
-          <p:cNvPr id="2" name="Text Placeholder 1">
+          <p:cNvPr id="80" name="Google Shape;80;p16"/>
+          <p:cNvSpPr txBox="1">
+            <a:spLocks noGrp="1"/>
+          </p:cNvSpPr>
+          <p:nvPr>
+            <p:ph type="title"/>
+          </p:nvPr>
+        </p:nvSpPr>
+        <p:spPr>
+          <a:xfrm>
+            <a:off x="443306" y="415210"/>
+            <a:ext cx="12118187" cy="814507"/>
+          </a:xfrm>
+          <a:prstGeom prst="rect">
+            <a:avLst/>
+          </a:prstGeom>
+        </p:spPr>
+        <p:txBody>
+          <a:bodyPr spcFirstLastPara="1" wrap="square" lIns="130027" tIns="130027" rIns="130027" bIns="130027" anchor="t" anchorCtr="0">
+            <a:noAutofit/>
+          </a:bodyPr>
+          <a:lstStyle/>
+          <a:p>
+            <a:r>
+              <a:rPr lang="en" dirty="0"/>
+              <a:t>Data Science Lifecycle</a:t>
+            </a:r>
+            <a:endParaRPr dirty="0"/>
+          </a:p>
+        </p:txBody>
+      </p:sp>
+      <p:sp>
+        <p:nvSpPr>
+          <p:cNvPr id="4" name="Try to explain your ideas and question solutions that don’t make sense to them.…">
             <a:extLst>
               <a:ext uri="{FF2B5EF4-FFF2-40B4-BE49-F238E27FC236}">
-                <a16:creationId xmlns:a16="http://schemas.microsoft.com/office/drawing/2014/main" id="{6D2D030B-7C16-A440-BD57-5A9A7EC600AE}"/>
+                <a16:creationId xmlns:a16="http://schemas.microsoft.com/office/drawing/2014/main" id="{BA0D7F05-4D86-ECD2-6C10-E0921FD80C52}"/>
               </a:ext>
             </a:extLst>
           </p:cNvPr>
-          <p:cNvSpPr>
+          <p:cNvSpPr txBox="1">
             <a:spLocks noGrp="1"/>
           </p:cNvSpPr>
           <p:nvPr>
-            <p:ph type="body" sz="quarter" idx="1"/>
+            <p:ph type="body" idx="1"/>
           </p:nvPr>
         </p:nvSpPr>
-        <p:spPr/>
+        <p:spPr>
+          <a:xfrm>
+            <a:off x="650238" y="2787462"/>
+            <a:ext cx="11704322" cy="5638081"/>
+          </a:xfrm>
+          <a:prstGeom prst="rect">
+            <a:avLst/>
+          </a:prstGeom>
+        </p:spPr>
         <p:txBody>
-          <a:bodyPr/>
+          <a:bodyPr>
+            <a:normAutofit/>
+          </a:bodyPr>
           <a:lstStyle/>
           <a:p>
-            <a:r>
-              <a:rPr lang="en-US" dirty="0"/>
-              <a:t>Python and </a:t>
-            </a:r>
-            <a:r>
-              <a:rPr lang="en-US" dirty="0" err="1"/>
-              <a:t>Jupyter</a:t>
-            </a:r>
-            <a:r>
-              <a:rPr lang="en-US" dirty="0"/>
-              <a:t> Demo</a:t>
-            </a:r>
+            <a:pPr>
+              <a:defRPr sz="4000"/>
+            </a:pPr>
+            <a:r>
+              <a:rPr lang="en-GB" sz="4400" dirty="0"/>
+              <a:t>1) Ask a question</a:t>
+            </a:r>
+          </a:p>
+          <a:p>
+            <a:pPr>
+              <a:defRPr sz="4000"/>
+            </a:pPr>
+            <a:r>
+              <a:rPr lang="en-GB" sz="4400" dirty="0"/>
+              <a:t>2) Obtain some data</a:t>
+            </a:r>
+          </a:p>
+          <a:p>
+            <a:pPr>
+              <a:defRPr sz="4000"/>
+            </a:pPr>
+            <a:r>
+              <a:rPr lang="en-GB" sz="4400" dirty="0"/>
+              <a:t>3) Understand the data</a:t>
+            </a:r>
+          </a:p>
+          <a:p>
+            <a:pPr>
+              <a:defRPr sz="4000"/>
+            </a:pPr>
+            <a:r>
+              <a:rPr lang="en-GB" sz="4400" dirty="0"/>
+              <a:t>4) Understand the World</a:t>
+            </a:r>
+          </a:p>
+          <a:p>
+            <a:pPr>
+              <a:defRPr sz="4000"/>
+            </a:pPr>
+            <a:r>
+              <a:rPr lang="en-GB" sz="4400" dirty="0"/>
+              <a:t>5) Report Results</a:t>
+            </a:r>
+            <a:endParaRPr sz="4400" dirty="0"/>
           </a:p>
         </p:txBody>
       </p:sp>
     </p:spTree>
+    <p:extLst>
+      <p:ext uri="{BB962C8B-B14F-4D97-AF65-F5344CB8AC3E}">
+        <p14:creationId xmlns:p14="http://schemas.microsoft.com/office/powerpoint/2010/main" val="1662858709"/>
+      </p:ext>
+    </p:extLst>
+  </p:cSld>
+  <p:clrMapOvr>
+    <a:masterClrMapping/>
+  </p:clrMapOvr>
+  <p:transition spd="med"/>
+  <p:timing>
+    <p:tnLst>
+      <p:par>
+        <p:cTn id="1" dur="indefinite" restart="never" nodeType="tmRoot">
+          <p:childTnLst>
+            <p:seq concurrent="1" nextAc="seek">
+              <p:cTn id="2" dur="indefinite" nodeType="mainSeq">
+                <p:childTnLst>
+                  <p:par>
+                    <p:cTn id="3" fill="hold">
+                      <p:stCondLst>
+                        <p:cond delay="indefinite"/>
+                      </p:stCondLst>
+                      <p:childTnLst>
+                        <p:par>
+                          <p:cTn id="4" fill="hold">
+                            <p:stCondLst>
+                              <p:cond delay="0"/>
+                            </p:stCondLst>
+                            <p:childTnLst>
+                              <p:par>
+                                <p:cTn id="5" presetID="1" presetClass="entr" presetSubtype="0" fill="hold" grpId="0" nodeType="clickEffect">
+                                  <p:stCondLst>
+                                    <p:cond delay="0"/>
+                                  </p:stCondLst>
+                                  <p:iterate>
+                                    <p:tmAbs val="0"/>
+                                  </p:iterate>
+                                  <p:childTnLst>
+                                    <p:set>
+                                      <p:cBhvr>
+                                        <p:cTn id="6" fill="hold"/>
+                                        <p:tgtEl>
+                                          <p:spTgt spid="4">
+                                            <p:bg/>
+                                          </p:spTgt>
+                                        </p:tgtEl>
+                                        <p:attrNameLst>
+                                          <p:attrName>style.visibility</p:attrName>
+                                        </p:attrNameLst>
+                                      </p:cBhvr>
+                                      <p:to>
+                                        <p:strVal val="visible"/>
+                                      </p:to>
+                                    </p:set>
+                                  </p:childTnLst>
+                                </p:cTn>
+                              </p:par>
+                            </p:childTnLst>
+                          </p:cTn>
+                        </p:par>
+                      </p:childTnLst>
+                    </p:cTn>
+                  </p:par>
+                  <p:par>
+                    <p:cTn id="7" fill="hold">
+                      <p:stCondLst>
+                        <p:cond delay="indefinite"/>
+                      </p:stCondLst>
+                      <p:childTnLst>
+                        <p:par>
+                          <p:cTn id="8" fill="hold">
+                            <p:stCondLst>
+                              <p:cond delay="0"/>
+                            </p:stCondLst>
+                            <p:childTnLst>
+                              <p:par>
+                                <p:cTn id="9" presetID="1" presetClass="entr" presetSubtype="0" fill="hold" grpId="0" nodeType="clickEffect">
+                                  <p:stCondLst>
+                                    <p:cond delay="0"/>
+                                  </p:stCondLst>
+                                  <p:iterate>
+                                    <p:tmAbs val="0"/>
+                                  </p:iterate>
+                                  <p:childTnLst>
+                                    <p:set>
+                                      <p:cBhvr>
+                                        <p:cTn id="10" fill="hold"/>
+                                        <p:tgtEl>
+                                          <p:spTgt spid="4">
+                                            <p:txEl>
+                                              <p:pRg st="0" end="0"/>
+                                            </p:txEl>
+                                          </p:spTgt>
+                                        </p:tgtEl>
+                                        <p:attrNameLst>
+                                          <p:attrName>style.visibility</p:attrName>
+                                        </p:attrNameLst>
+                                      </p:cBhvr>
+                                      <p:to>
+                                        <p:strVal val="visible"/>
+                                      </p:to>
+                                    </p:set>
+                                  </p:childTnLst>
+                                </p:cTn>
+                              </p:par>
+                            </p:childTnLst>
+                          </p:cTn>
+                        </p:par>
+                      </p:childTnLst>
+                    </p:cTn>
+                  </p:par>
+                  <p:par>
+                    <p:cTn id="11" fill="hold">
+                      <p:stCondLst>
+                        <p:cond delay="indefinite"/>
+                      </p:stCondLst>
+                      <p:childTnLst>
+                        <p:par>
+                          <p:cTn id="12" fill="hold">
+                            <p:stCondLst>
+                              <p:cond delay="0"/>
+                            </p:stCondLst>
+                            <p:childTnLst>
+                              <p:par>
+                                <p:cTn id="13" presetID="1" presetClass="entr" presetSubtype="0" fill="hold" grpId="0" nodeType="clickEffect">
+                                  <p:stCondLst>
+                                    <p:cond delay="0"/>
+                                  </p:stCondLst>
+                                  <p:iterate>
+                                    <p:tmAbs val="0"/>
+                                  </p:iterate>
+                                  <p:childTnLst>
+                                    <p:set>
+                                      <p:cBhvr>
+                                        <p:cTn id="14" fill="hold"/>
+                                        <p:tgtEl>
+                                          <p:spTgt spid="4">
+                                            <p:txEl>
+                                              <p:pRg st="1" end="1"/>
+                                            </p:txEl>
+                                          </p:spTgt>
+                                        </p:tgtEl>
+                                        <p:attrNameLst>
+                                          <p:attrName>style.visibility</p:attrName>
+                                        </p:attrNameLst>
+                                      </p:cBhvr>
+                                      <p:to>
+                                        <p:strVal val="visible"/>
+                                      </p:to>
+                                    </p:set>
+                                  </p:childTnLst>
+                                </p:cTn>
+                              </p:par>
+                            </p:childTnLst>
+                          </p:cTn>
+                        </p:par>
+                      </p:childTnLst>
+                    </p:cTn>
+                  </p:par>
+                  <p:par>
+                    <p:cTn id="15" fill="hold">
+                      <p:stCondLst>
+                        <p:cond delay="indefinite"/>
+                      </p:stCondLst>
+                      <p:childTnLst>
+                        <p:par>
+                          <p:cTn id="16" fill="hold">
+                            <p:stCondLst>
+                              <p:cond delay="0"/>
+                            </p:stCondLst>
+                            <p:childTnLst>
+                              <p:par>
+                                <p:cTn id="17" presetID="1" presetClass="entr" presetSubtype="0" fill="hold" grpId="0" nodeType="clickEffect">
+                                  <p:stCondLst>
+                                    <p:cond delay="0"/>
+                                  </p:stCondLst>
+                                  <p:iterate>
+                                    <p:tmAbs val="0"/>
+                                  </p:iterate>
+                                  <p:childTnLst>
+                                    <p:set>
+                                      <p:cBhvr>
+                                        <p:cTn id="18" fill="hold"/>
+                                        <p:tgtEl>
+                                          <p:spTgt spid="4">
+                                            <p:txEl>
+                                              <p:pRg st="2" end="2"/>
+                                            </p:txEl>
+                                          </p:spTgt>
+                                        </p:tgtEl>
+                                        <p:attrNameLst>
+                                          <p:attrName>style.visibility</p:attrName>
+                                        </p:attrNameLst>
+                                      </p:cBhvr>
+                                      <p:to>
+                                        <p:strVal val="visible"/>
+                                      </p:to>
+                                    </p:set>
+                                  </p:childTnLst>
+                                </p:cTn>
+                              </p:par>
+                            </p:childTnLst>
+                          </p:cTn>
+                        </p:par>
+                      </p:childTnLst>
+                    </p:cTn>
+                  </p:par>
+                  <p:par>
+                    <p:cTn id="19" fill="hold">
+                      <p:stCondLst>
+                        <p:cond delay="indefinite"/>
+                      </p:stCondLst>
+                      <p:childTnLst>
+                        <p:par>
+                          <p:cTn id="20" fill="hold">
+                            <p:stCondLst>
+                              <p:cond delay="0"/>
+                            </p:stCondLst>
+                            <p:childTnLst>
+                              <p:par>
+                                <p:cTn id="21" presetID="1" presetClass="entr" presetSubtype="0" fill="hold" grpId="0" nodeType="clickEffect">
+                                  <p:stCondLst>
+                                    <p:cond delay="0"/>
+                                  </p:stCondLst>
+                                  <p:iterate>
+                                    <p:tmAbs val="0"/>
+                                  </p:iterate>
+                                  <p:childTnLst>
+                                    <p:set>
+                                      <p:cBhvr>
+                                        <p:cTn id="22" fill="hold"/>
+                                        <p:tgtEl>
+                                          <p:spTgt spid="4">
+                                            <p:txEl>
+                                              <p:pRg st="3" end="3"/>
+                                            </p:txEl>
+                                          </p:spTgt>
+                                        </p:tgtEl>
+                                        <p:attrNameLst>
+                                          <p:attrName>style.visibility</p:attrName>
+                                        </p:attrNameLst>
+                                      </p:cBhvr>
+                                      <p:to>
+                                        <p:strVal val="visible"/>
+                                      </p:to>
+                                    </p:set>
+                                  </p:childTnLst>
+                                </p:cTn>
+                              </p:par>
+                            </p:childTnLst>
+                          </p:cTn>
+                        </p:par>
+                      </p:childTnLst>
+                    </p:cTn>
+                  </p:par>
+                  <p:par>
+                    <p:cTn id="23" fill="hold">
+                      <p:stCondLst>
+                        <p:cond delay="indefinite"/>
+                      </p:stCondLst>
+                      <p:childTnLst>
+                        <p:par>
+                          <p:cTn id="24" fill="hold">
+                            <p:stCondLst>
+                              <p:cond delay="0"/>
+                            </p:stCondLst>
+                            <p:childTnLst>
+                              <p:par>
+                                <p:cTn id="25" presetID="1" presetClass="entr" presetSubtype="0" fill="hold" grpId="0" nodeType="clickEffect">
+                                  <p:stCondLst>
+                                    <p:cond delay="0"/>
+                                  </p:stCondLst>
+                                  <p:iterate>
+                                    <p:tmAbs val="0"/>
+                                  </p:iterate>
+                                  <p:childTnLst>
+                                    <p:set>
+                                      <p:cBhvr>
+                                        <p:cTn id="26" fill="hold"/>
+                                        <p:tgtEl>
+                                          <p:spTgt spid="4">
+                                            <p:txEl>
+                                              <p:pRg st="4" end="4"/>
+                                            </p:txEl>
+                                          </p:spTgt>
+                                        </p:tgtEl>
+                                        <p:attrNameLst>
+                                          <p:attrName>style.visibility</p:attrName>
+                                        </p:attrNameLst>
+                                      </p:cBhvr>
+                                      <p:to>
+                                        <p:strVal val="visible"/>
+                                      </p:to>
+                                    </p:set>
+                                  </p:childTnLst>
+                                </p:cTn>
+                              </p:par>
+                            </p:childTnLst>
+                          </p:cTn>
+                        </p:par>
+                      </p:childTnLst>
+                    </p:cTn>
+                  </p:par>
+                </p:childTnLst>
+              </p:cTn>
+              <p:prevCondLst>
+                <p:cond evt="onPrev" delay="0">
+                  <p:tgtEl>
+                    <p:sldTgt/>
+                  </p:tgtEl>
+                </p:cond>
+              </p:prevCondLst>
+              <p:nextCondLst>
+                <p:cond evt="onNext" delay="0">
+                  <p:tgtEl>
+                    <p:sldTgt/>
+                  </p:tgtEl>
+                </p:cond>
+              </p:nextCondLst>
+            </p:seq>
+          </p:childTnLst>
+        </p:cTn>
+      </p:par>
+    </p:tnLst>
+    <p:bldLst>
+      <p:bldP spid="4" grpId="0" uiExpand="1" build="p" bldLvl="5" animBg="1" advAuto="0"/>
+    </p:bldLst>
+  </p:timing>
+</p:sld>
+</file>
+
+<file path=ppt/slides/slide26.xml><?xml version="1.0" encoding="utf-8"?>
+<p:sld xmlns:a="http://schemas.openxmlformats.org/drawingml/2006/main" xmlns:r="http://schemas.openxmlformats.org/officeDocument/2006/relationships" xmlns:p="http://schemas.openxmlformats.org/presentationml/2006/main">
+  <p:cSld>
+    <p:spTree>
+      <p:nvGrpSpPr>
+        <p:cNvPr id="1" name="Shape 79">
+          <a:extLst>
+            <a:ext uri="{FF2B5EF4-FFF2-40B4-BE49-F238E27FC236}">
+              <a16:creationId xmlns:a16="http://schemas.microsoft.com/office/drawing/2014/main" id="{B5D8F852-1EC0-0FD1-1EE6-839C085F6A40}"/>
+            </a:ext>
+          </a:extLst>
+        </p:cNvPr>
+        <p:cNvGrpSpPr/>
+        <p:nvPr/>
+      </p:nvGrpSpPr>
+      <p:grpSpPr>
+        <a:xfrm>
+          <a:off x="0" y="0"/>
+          <a:ext cx="0" cy="0"/>
+          <a:chOff x="0" y="0"/>
+          <a:chExt cx="0" cy="0"/>
+        </a:xfrm>
+      </p:grpSpPr>
+      <p:sp>
+        <p:nvSpPr>
+          <p:cNvPr id="80" name="Google Shape;80;p16">
+            <a:extLst>
+              <a:ext uri="{FF2B5EF4-FFF2-40B4-BE49-F238E27FC236}">
+                <a16:creationId xmlns:a16="http://schemas.microsoft.com/office/drawing/2014/main" id="{0FD65145-2614-C671-1728-8F472C2205C6}"/>
+              </a:ext>
+            </a:extLst>
+          </p:cNvPr>
+          <p:cNvSpPr txBox="1">
+            <a:spLocks noGrp="1"/>
+          </p:cNvSpPr>
+          <p:nvPr>
+            <p:ph type="title"/>
+          </p:nvPr>
+        </p:nvSpPr>
+        <p:spPr>
+          <a:xfrm>
+            <a:off x="443306" y="415210"/>
+            <a:ext cx="12118187" cy="814507"/>
+          </a:xfrm>
+          <a:prstGeom prst="rect">
+            <a:avLst/>
+          </a:prstGeom>
+        </p:spPr>
+        <p:txBody>
+          <a:bodyPr spcFirstLastPara="1" wrap="square" lIns="130027" tIns="130027" rIns="130027" bIns="130027" anchor="t" anchorCtr="0">
+            <a:noAutofit/>
+          </a:bodyPr>
+          <a:lstStyle/>
+          <a:p>
+            <a:r>
+              <a:rPr lang="en" dirty="0"/>
+              <a:t>Data Science Lifecycle</a:t>
+            </a:r>
+            <a:endParaRPr dirty="0"/>
+          </a:p>
+        </p:txBody>
+      </p:sp>
+      <p:sp>
+        <p:nvSpPr>
+          <p:cNvPr id="4" name="Try to explain your ideas and question solutions that don’t make sense to them.…">
+            <a:extLst>
+              <a:ext uri="{FF2B5EF4-FFF2-40B4-BE49-F238E27FC236}">
+                <a16:creationId xmlns:a16="http://schemas.microsoft.com/office/drawing/2014/main" id="{1E6D759A-973C-5C98-4239-4D387C64DA49}"/>
+              </a:ext>
+            </a:extLst>
+          </p:cNvPr>
+          <p:cNvSpPr txBox="1">
+            <a:spLocks noGrp="1"/>
+          </p:cNvSpPr>
+          <p:nvPr>
+            <p:ph type="body" idx="1"/>
+          </p:nvPr>
+        </p:nvSpPr>
+        <p:spPr>
+          <a:xfrm>
+            <a:off x="650238" y="2787462"/>
+            <a:ext cx="11704322" cy="5638081"/>
+          </a:xfrm>
+          <a:prstGeom prst="rect">
+            <a:avLst/>
+          </a:prstGeom>
+        </p:spPr>
+        <p:txBody>
+          <a:bodyPr>
+            <a:normAutofit/>
+          </a:bodyPr>
+          <a:lstStyle/>
+          <a:p>
+            <a:pPr>
+              <a:defRPr sz="4000"/>
+            </a:pPr>
+            <a:r>
+              <a:rPr lang="en-GB" sz="4400" dirty="0"/>
+              <a:t>1) Ask a question</a:t>
+            </a:r>
+          </a:p>
+          <a:p>
+            <a:pPr>
+              <a:defRPr sz="4000"/>
+            </a:pPr>
+            <a:r>
+              <a:rPr lang="en-GB" sz="4400" dirty="0"/>
+              <a:t>2) Obtain some data</a:t>
+            </a:r>
+          </a:p>
+          <a:p>
+            <a:pPr>
+              <a:defRPr sz="4000"/>
+            </a:pPr>
+            <a:r>
+              <a:rPr lang="en-GB" sz="4400" dirty="0"/>
+              <a:t>3) Understand the data</a:t>
+            </a:r>
+          </a:p>
+          <a:p>
+            <a:pPr>
+              <a:defRPr sz="4000"/>
+            </a:pPr>
+            <a:r>
+              <a:rPr lang="en-GB" sz="4400" dirty="0"/>
+              <a:t>4) Understand the World</a:t>
+            </a:r>
+          </a:p>
+          <a:p>
+            <a:pPr>
+              <a:defRPr sz="4000"/>
+            </a:pPr>
+            <a:r>
+              <a:rPr lang="en-GB" sz="4400" dirty="0"/>
+              <a:t>5) Report Results</a:t>
+            </a:r>
+            <a:endParaRPr sz="4400" dirty="0"/>
+          </a:p>
+        </p:txBody>
+      </p:sp>
+      <p:sp>
+        <p:nvSpPr>
+          <p:cNvPr id="2" name="Line">
+            <a:extLst>
+              <a:ext uri="{FF2B5EF4-FFF2-40B4-BE49-F238E27FC236}">
+                <a16:creationId xmlns:a16="http://schemas.microsoft.com/office/drawing/2014/main" id="{B4D33A48-AE00-7EA8-B750-EC191070024A}"/>
+              </a:ext>
+            </a:extLst>
+          </p:cNvPr>
+          <p:cNvSpPr/>
+          <p:nvPr/>
+        </p:nvSpPr>
+        <p:spPr>
+          <a:xfrm>
+            <a:off x="684817" y="785508"/>
+            <a:ext cx="5817583" cy="9080759"/>
+          </a:xfrm>
+          <a:prstGeom prst="line">
+            <a:avLst/>
+          </a:prstGeom>
+          <a:ln w="279400">
+            <a:solidFill>
+              <a:schemeClr val="accent5"/>
+            </a:solidFill>
+            <a:miter lim="400000"/>
+          </a:ln>
+        </p:spPr>
+        <p:txBody>
+          <a:bodyPr lIns="50800" tIns="50800" rIns="50800" bIns="50800" anchor="ctr"/>
+          <a:lstStyle/>
+          <a:p>
+            <a:pPr>
+              <a:defRPr sz="2400"/>
+            </a:pPr>
+            <a:endParaRPr/>
+          </a:p>
+        </p:txBody>
+      </p:sp>
+      <p:sp>
+        <p:nvSpPr>
+          <p:cNvPr id="3" name="Line">
+            <a:extLst>
+              <a:ext uri="{FF2B5EF4-FFF2-40B4-BE49-F238E27FC236}">
+                <a16:creationId xmlns:a16="http://schemas.microsoft.com/office/drawing/2014/main" id="{3B36575F-10FA-B14E-DDA7-539E62C697DE}"/>
+              </a:ext>
+            </a:extLst>
+          </p:cNvPr>
+          <p:cNvSpPr/>
+          <p:nvPr/>
+        </p:nvSpPr>
+        <p:spPr>
+          <a:xfrm flipH="1">
+            <a:off x="880671" y="898174"/>
+            <a:ext cx="5425873" cy="8855426"/>
+          </a:xfrm>
+          <a:prstGeom prst="line">
+            <a:avLst/>
+          </a:prstGeom>
+          <a:ln w="279400">
+            <a:solidFill>
+              <a:schemeClr val="accent5"/>
+            </a:solidFill>
+            <a:miter lim="400000"/>
+          </a:ln>
+        </p:spPr>
+        <p:txBody>
+          <a:bodyPr lIns="50800" tIns="50800" rIns="50800" bIns="50800" anchor="ctr"/>
+          <a:lstStyle/>
+          <a:p>
+            <a:pPr>
+              <a:defRPr sz="2400"/>
+            </a:pPr>
+            <a:endParaRPr/>
+          </a:p>
+        </p:txBody>
+      </p:sp>
+    </p:spTree>
+    <p:extLst>
+      <p:ext uri="{BB962C8B-B14F-4D97-AF65-F5344CB8AC3E}">
+        <p14:creationId xmlns:p14="http://schemas.microsoft.com/office/powerpoint/2010/main" val="3582209206"/>
+      </p:ext>
+    </p:extLst>
+  </p:cSld>
+  <p:clrMapOvr>
+    <a:masterClrMapping/>
+  </p:clrMapOvr>
+  <p:transition spd="med"/>
+</p:sld>
+</file>
+
+<file path=ppt/slides/slide27.xml><?xml version="1.0" encoding="utf-8"?>
+<p:sld xmlns:a="http://schemas.openxmlformats.org/drawingml/2006/main" xmlns:r="http://schemas.openxmlformats.org/officeDocument/2006/relationships" xmlns:p="http://schemas.openxmlformats.org/presentationml/2006/main">
+  <p:cSld>
+    <p:spTree>
+      <p:nvGrpSpPr>
+        <p:cNvPr id="1" name="Shape 79">
+          <a:extLst>
+            <a:ext uri="{FF2B5EF4-FFF2-40B4-BE49-F238E27FC236}">
+              <a16:creationId xmlns:a16="http://schemas.microsoft.com/office/drawing/2014/main" id="{129AF3FF-7035-AD23-ADD1-938A94D21CDE}"/>
+            </a:ext>
+          </a:extLst>
+        </p:cNvPr>
+        <p:cNvGrpSpPr/>
+        <p:nvPr/>
+      </p:nvGrpSpPr>
+      <p:grpSpPr>
+        <a:xfrm>
+          <a:off x="0" y="0"/>
+          <a:ext cx="0" cy="0"/>
+          <a:chOff x="0" y="0"/>
+          <a:chExt cx="0" cy="0"/>
+        </a:xfrm>
+      </p:grpSpPr>
+      <p:pic>
+        <p:nvPicPr>
+          <p:cNvPr id="81" name="Google Shape;81;p16">
+            <a:extLst>
+              <a:ext uri="{FF2B5EF4-FFF2-40B4-BE49-F238E27FC236}">
+                <a16:creationId xmlns:a16="http://schemas.microsoft.com/office/drawing/2014/main" id="{88EAE2E2-5F18-606F-6F1E-32BEDB7AFCE5}"/>
+              </a:ext>
+            </a:extLst>
+          </p:cNvPr>
+          <p:cNvPicPr preferRelativeResize="0"/>
+          <p:nvPr/>
+        </p:nvPicPr>
+        <p:blipFill>
+          <a:blip r:embed="rId3">
+            <a:alphaModFix/>
+          </a:blip>
+          <a:stretch>
+            <a:fillRect/>
+          </a:stretch>
+        </p:blipFill>
+        <p:spPr>
+          <a:xfrm>
+            <a:off x="1132114" y="2220686"/>
+            <a:ext cx="10297886" cy="7335419"/>
+          </a:xfrm>
+          <a:prstGeom prst="rect">
+            <a:avLst/>
+          </a:prstGeom>
+          <a:noFill/>
+          <a:ln>
+            <a:noFill/>
+          </a:ln>
+        </p:spPr>
+      </p:pic>
+      <p:sp>
+        <p:nvSpPr>
+          <p:cNvPr id="4" name="Google Shape;80;p16">
+            <a:extLst>
+              <a:ext uri="{FF2B5EF4-FFF2-40B4-BE49-F238E27FC236}">
+                <a16:creationId xmlns:a16="http://schemas.microsoft.com/office/drawing/2014/main" id="{F14A0578-75BB-1E4F-A9E6-2BA34D8E34FF}"/>
+              </a:ext>
+            </a:extLst>
+          </p:cNvPr>
+          <p:cNvSpPr txBox="1">
+            <a:spLocks/>
+          </p:cNvSpPr>
+          <p:nvPr/>
+        </p:nvSpPr>
+        <p:spPr>
+          <a:xfrm>
+            <a:off x="443306" y="415210"/>
+            <a:ext cx="12118187" cy="814507"/>
+          </a:xfrm>
+          <a:prstGeom prst="rect">
+            <a:avLst/>
+          </a:prstGeom>
+          <a:ln w="12700">
+            <a:miter lim="400000"/>
+          </a:ln>
+          <a:extLst>
+            <a:ext uri="{C572A759-6A51-4108-AA02-DFA0A04FC94B}">
+              <ma14:wrappingTextBoxFlag xmlns:ma14="http://schemas.microsoft.com/office/mac/drawingml/2011/main" xmlns:a14="http://schemas.microsoft.com/office/drawing/2010/main" xmlns:m="http://schemas.openxmlformats.org/officeDocument/2006/math" xmlns="" val="1"/>
+            </a:ext>
+          </a:extLst>
+        </p:spPr>
+        <p:txBody>
+          <a:bodyPr spcFirstLastPara="1" wrap="square" lIns="130027" tIns="130027" rIns="130027" bIns="130027" anchor="t" anchorCtr="0">
+            <a:noAutofit/>
+          </a:bodyPr>
+          <a:lstStyle>
+            <a:lvl1pPr marL="0" marR="0" indent="0" algn="ctr" defTabSz="584200" rtl="0" latinLnBrk="0">
+              <a:lnSpc>
+                <a:spcPct val="100000"/>
+              </a:lnSpc>
+              <a:spcBef>
+                <a:spcPts val="0"/>
+              </a:spcBef>
+              <a:spcAft>
+                <a:spcPts val="0"/>
+              </a:spcAft>
+              <a:buClrTx/>
+              <a:buSzTx/>
+              <a:buFontTx/>
+              <a:buNone/>
+              <a:tabLst/>
+              <a:defRPr sz="8000" b="0" i="0" u="none" strike="noStrike" cap="none" spc="0" baseline="0">
+                <a:solidFill>
+                  <a:srgbClr val="000000"/>
+                </a:solidFill>
+                <a:uFillTx/>
+                <a:latin typeface="+mn-lt"/>
+                <a:ea typeface="+mn-ea"/>
+                <a:cs typeface="+mn-cs"/>
+                <a:sym typeface="Helvetica Light"/>
+              </a:defRPr>
+            </a:lvl1pPr>
+            <a:lvl2pPr marL="0" marR="0" indent="228600" algn="ctr" defTabSz="584200" rtl="0" latinLnBrk="0">
+              <a:lnSpc>
+                <a:spcPct val="100000"/>
+              </a:lnSpc>
+              <a:spcBef>
+                <a:spcPts val="0"/>
+              </a:spcBef>
+              <a:spcAft>
+                <a:spcPts val="0"/>
+              </a:spcAft>
+              <a:buClrTx/>
+              <a:buSzTx/>
+              <a:buFontTx/>
+              <a:buNone/>
+              <a:tabLst/>
+              <a:defRPr sz="8000" b="0" i="0" u="none" strike="noStrike" cap="none" spc="0" baseline="0">
+                <a:solidFill>
+                  <a:srgbClr val="000000"/>
+                </a:solidFill>
+                <a:uFillTx/>
+                <a:latin typeface="+mn-lt"/>
+                <a:ea typeface="+mn-ea"/>
+                <a:cs typeface="+mn-cs"/>
+                <a:sym typeface="Helvetica Light"/>
+              </a:defRPr>
+            </a:lvl2pPr>
+            <a:lvl3pPr marL="0" marR="0" indent="457200" algn="ctr" defTabSz="584200" rtl="0" latinLnBrk="0">
+              <a:lnSpc>
+                <a:spcPct val="100000"/>
+              </a:lnSpc>
+              <a:spcBef>
+                <a:spcPts val="0"/>
+              </a:spcBef>
+              <a:spcAft>
+                <a:spcPts val="0"/>
+              </a:spcAft>
+              <a:buClrTx/>
+              <a:buSzTx/>
+              <a:buFontTx/>
+              <a:buNone/>
+              <a:tabLst/>
+              <a:defRPr sz="8000" b="0" i="0" u="none" strike="noStrike" cap="none" spc="0" baseline="0">
+                <a:solidFill>
+                  <a:srgbClr val="000000"/>
+                </a:solidFill>
+                <a:uFillTx/>
+                <a:latin typeface="+mn-lt"/>
+                <a:ea typeface="+mn-ea"/>
+                <a:cs typeface="+mn-cs"/>
+                <a:sym typeface="Helvetica Light"/>
+              </a:defRPr>
+            </a:lvl3pPr>
+            <a:lvl4pPr marL="0" marR="0" indent="685800" algn="ctr" defTabSz="584200" rtl="0" latinLnBrk="0">
+              <a:lnSpc>
+                <a:spcPct val="100000"/>
+              </a:lnSpc>
+              <a:spcBef>
+                <a:spcPts val="0"/>
+              </a:spcBef>
+              <a:spcAft>
+                <a:spcPts val="0"/>
+              </a:spcAft>
+              <a:buClrTx/>
+              <a:buSzTx/>
+              <a:buFontTx/>
+              <a:buNone/>
+              <a:tabLst/>
+              <a:defRPr sz="8000" b="0" i="0" u="none" strike="noStrike" cap="none" spc="0" baseline="0">
+                <a:solidFill>
+                  <a:srgbClr val="000000"/>
+                </a:solidFill>
+                <a:uFillTx/>
+                <a:latin typeface="+mn-lt"/>
+                <a:ea typeface="+mn-ea"/>
+                <a:cs typeface="+mn-cs"/>
+                <a:sym typeface="Helvetica Light"/>
+              </a:defRPr>
+            </a:lvl4pPr>
+            <a:lvl5pPr marL="0" marR="0" indent="914400" algn="ctr" defTabSz="584200" rtl="0" latinLnBrk="0">
+              <a:lnSpc>
+                <a:spcPct val="100000"/>
+              </a:lnSpc>
+              <a:spcBef>
+                <a:spcPts val="0"/>
+              </a:spcBef>
+              <a:spcAft>
+                <a:spcPts val="0"/>
+              </a:spcAft>
+              <a:buClrTx/>
+              <a:buSzTx/>
+              <a:buFontTx/>
+              <a:buNone/>
+              <a:tabLst/>
+              <a:defRPr sz="8000" b="0" i="0" u="none" strike="noStrike" cap="none" spc="0" baseline="0">
+                <a:solidFill>
+                  <a:srgbClr val="000000"/>
+                </a:solidFill>
+                <a:uFillTx/>
+                <a:latin typeface="+mn-lt"/>
+                <a:ea typeface="+mn-ea"/>
+                <a:cs typeface="+mn-cs"/>
+                <a:sym typeface="Helvetica Light"/>
+              </a:defRPr>
+            </a:lvl5pPr>
+            <a:lvl6pPr marL="0" marR="0" indent="1143000" algn="ctr" defTabSz="584200" rtl="0" latinLnBrk="0">
+              <a:lnSpc>
+                <a:spcPct val="100000"/>
+              </a:lnSpc>
+              <a:spcBef>
+                <a:spcPts val="0"/>
+              </a:spcBef>
+              <a:spcAft>
+                <a:spcPts val="0"/>
+              </a:spcAft>
+              <a:buClrTx/>
+              <a:buSzTx/>
+              <a:buFontTx/>
+              <a:buNone/>
+              <a:tabLst/>
+              <a:defRPr sz="8000" b="0" i="0" u="none" strike="noStrike" cap="none" spc="0" baseline="0">
+                <a:solidFill>
+                  <a:srgbClr val="000000"/>
+                </a:solidFill>
+                <a:uFillTx/>
+                <a:latin typeface="+mn-lt"/>
+                <a:ea typeface="+mn-ea"/>
+                <a:cs typeface="+mn-cs"/>
+                <a:sym typeface="Helvetica Light"/>
+              </a:defRPr>
+            </a:lvl6pPr>
+            <a:lvl7pPr marL="0" marR="0" indent="1371600" algn="ctr" defTabSz="584200" rtl="0" latinLnBrk="0">
+              <a:lnSpc>
+                <a:spcPct val="100000"/>
+              </a:lnSpc>
+              <a:spcBef>
+                <a:spcPts val="0"/>
+              </a:spcBef>
+              <a:spcAft>
+                <a:spcPts val="0"/>
+              </a:spcAft>
+              <a:buClrTx/>
+              <a:buSzTx/>
+              <a:buFontTx/>
+              <a:buNone/>
+              <a:tabLst/>
+              <a:defRPr sz="8000" b="0" i="0" u="none" strike="noStrike" cap="none" spc="0" baseline="0">
+                <a:solidFill>
+                  <a:srgbClr val="000000"/>
+                </a:solidFill>
+                <a:uFillTx/>
+                <a:latin typeface="+mn-lt"/>
+                <a:ea typeface="+mn-ea"/>
+                <a:cs typeface="+mn-cs"/>
+                <a:sym typeface="Helvetica Light"/>
+              </a:defRPr>
+            </a:lvl7pPr>
+            <a:lvl8pPr marL="0" marR="0" indent="1600200" algn="ctr" defTabSz="584200" rtl="0" latinLnBrk="0">
+              <a:lnSpc>
+                <a:spcPct val="100000"/>
+              </a:lnSpc>
+              <a:spcBef>
+                <a:spcPts val="0"/>
+              </a:spcBef>
+              <a:spcAft>
+                <a:spcPts val="0"/>
+              </a:spcAft>
+              <a:buClrTx/>
+              <a:buSzTx/>
+              <a:buFontTx/>
+              <a:buNone/>
+              <a:tabLst/>
+              <a:defRPr sz="8000" b="0" i="0" u="none" strike="noStrike" cap="none" spc="0" baseline="0">
+                <a:solidFill>
+                  <a:srgbClr val="000000"/>
+                </a:solidFill>
+                <a:uFillTx/>
+                <a:latin typeface="+mn-lt"/>
+                <a:ea typeface="+mn-ea"/>
+                <a:cs typeface="+mn-cs"/>
+                <a:sym typeface="Helvetica Light"/>
+              </a:defRPr>
+            </a:lvl8pPr>
+            <a:lvl9pPr marL="0" marR="0" indent="1828800" algn="ctr" defTabSz="584200" rtl="0" latinLnBrk="0">
+              <a:lnSpc>
+                <a:spcPct val="100000"/>
+              </a:lnSpc>
+              <a:spcBef>
+                <a:spcPts val="0"/>
+              </a:spcBef>
+              <a:spcAft>
+                <a:spcPts val="0"/>
+              </a:spcAft>
+              <a:buClrTx/>
+              <a:buSzTx/>
+              <a:buFontTx/>
+              <a:buNone/>
+              <a:tabLst/>
+              <a:defRPr sz="8000" b="0" i="0" u="none" strike="noStrike" cap="none" spc="0" baseline="0">
+                <a:solidFill>
+                  <a:srgbClr val="000000"/>
+                </a:solidFill>
+                <a:uFillTx/>
+                <a:latin typeface="+mn-lt"/>
+                <a:ea typeface="+mn-ea"/>
+                <a:cs typeface="+mn-cs"/>
+                <a:sym typeface="Helvetica Light"/>
+              </a:defRPr>
+            </a:lvl9pPr>
+          </a:lstStyle>
+          <a:p>
+            <a:pPr hangingPunct="1"/>
+            <a:r>
+              <a:rPr lang="en-GB"/>
+              <a:t>Data Science Lifecycle</a:t>
+            </a:r>
+            <a:endParaRPr lang="en-GB" dirty="0"/>
+          </a:p>
+        </p:txBody>
+      </p:sp>
+    </p:spTree>
+    <p:extLst>
+      <p:ext uri="{BB962C8B-B14F-4D97-AF65-F5344CB8AC3E}">
+        <p14:creationId xmlns:p14="http://schemas.microsoft.com/office/powerpoint/2010/main" val="2606524415"/>
+      </p:ext>
+    </p:extLst>
   </p:cSld>
   <p:clrMapOvr>
     <a:masterClrMapping/>
@@ -15397,10 +16309,10 @@
       </p:sp>
       <p:pic>
         <p:nvPicPr>
-          <p:cNvPr id="5" name="Google Shape;104;p19">
+          <p:cNvPr id="10" name="Google Shape;104;p19">
             <a:extLst>
               <a:ext uri="{FF2B5EF4-FFF2-40B4-BE49-F238E27FC236}">
-                <a16:creationId xmlns:a16="http://schemas.microsoft.com/office/drawing/2014/main" id="{56A720D9-C417-754C-8170-B2FDDB771C9C}"/>
+                <a16:creationId xmlns:a16="http://schemas.microsoft.com/office/drawing/2014/main" id="{59DB5960-914A-A4A5-A957-3BDDD5CD2F1F}"/>
               </a:ext>
             </a:extLst>
           </p:cNvPr>
@@ -15408,7 +16320,7 @@
           <p:nvPr/>
         </p:nvPicPr>
         <p:blipFill>
-          <a:blip r:embed="rId2">
+          <a:blip r:embed="rId3">
             <a:alphaModFix/>
           </a:blip>
           <a:stretch>
@@ -15417,7 +16329,188 @@
         </p:blipFill>
         <p:spPr>
           <a:xfrm>
-            <a:off x="2553793" y="6159500"/>
+            <a:off x="952500" y="4590427"/>
+            <a:ext cx="3098966" cy="2772256"/>
+          </a:xfrm>
+          <a:prstGeom prst="rect">
+            <a:avLst/>
+          </a:prstGeom>
+          <a:noFill/>
+          <a:ln>
+            <a:noFill/>
+          </a:ln>
+        </p:spPr>
+      </p:pic>
+      <p:pic>
+        <p:nvPicPr>
+          <p:cNvPr id="11" name="Graphic 10">
+            <a:extLst>
+              <a:ext uri="{FF2B5EF4-FFF2-40B4-BE49-F238E27FC236}">
+                <a16:creationId xmlns:a16="http://schemas.microsoft.com/office/drawing/2014/main" id="{D86D8F8E-36EE-47D9-BDA1-484BD125BC7A}"/>
+              </a:ext>
+            </a:extLst>
+          </p:cNvPr>
+          <p:cNvPicPr>
+            <a:picLocks noChangeAspect="1"/>
+          </p:cNvPicPr>
+          <p:nvPr/>
+        </p:nvPicPr>
+        <p:blipFill>
+          <a:blip>
+            <a:extLst>
+              <a:ext uri="{28A0092B-C50C-407E-A947-70E740481C1C}">
+                <a14:useLocalDpi xmlns:a14="http://schemas.microsoft.com/office/drawing/2010/main" val="0"/>
+              </a:ext>
+              <a:ext uri="{96DAC541-7B7A-43D3-8B79-37D633B846F1}">
+                <asvg:svgBlip xmlns:asvg="http://schemas.microsoft.com/office/drawing/2016/SVG/main" r:embed="rId4"/>
+              </a:ext>
+            </a:extLst>
+          </a:blip>
+          <a:stretch>
+            <a:fillRect/>
+          </a:stretch>
+        </p:blipFill>
+        <p:spPr>
+          <a:xfrm>
+            <a:off x="6147124" y="4360857"/>
+            <a:ext cx="2806212" cy="3231395"/>
+          </a:xfrm>
+          <a:prstGeom prst="rect">
+            <a:avLst/>
+          </a:prstGeom>
+        </p:spPr>
+      </p:pic>
+    </p:spTree>
+    <p:extLst>
+      <p:ext uri="{BB962C8B-B14F-4D97-AF65-F5344CB8AC3E}">
+        <p14:creationId xmlns:p14="http://schemas.microsoft.com/office/powerpoint/2010/main" val="3044921591"/>
+      </p:ext>
+    </p:extLst>
+  </p:cSld>
+  <p:clrMapOvr>
+    <a:masterClrMapping/>
+  </p:clrMapOvr>
+  <p:transition spd="med"/>
+</p:sld>
+</file>
+
+<file path=ppt/slides/slide29.xml><?xml version="1.0" encoding="utf-8"?>
+<p:sld xmlns:a="http://schemas.openxmlformats.org/drawingml/2006/main" xmlns:r="http://schemas.openxmlformats.org/officeDocument/2006/relationships" xmlns:p="http://schemas.openxmlformats.org/presentationml/2006/main">
+  <p:cSld>
+    <p:spTree>
+      <p:nvGrpSpPr>
+        <p:cNvPr id="1" name="">
+          <a:extLst>
+            <a:ext uri="{FF2B5EF4-FFF2-40B4-BE49-F238E27FC236}">
+              <a16:creationId xmlns:a16="http://schemas.microsoft.com/office/drawing/2014/main" id="{06893C93-AEC9-3EDF-6186-8F7DE4081082}"/>
+            </a:ext>
+          </a:extLst>
+        </p:cNvPr>
+        <p:cNvGrpSpPr/>
+        <p:nvPr/>
+      </p:nvGrpSpPr>
+      <p:grpSpPr>
+        <a:xfrm>
+          <a:off x="0" y="0"/>
+          <a:ext cx="0" cy="0"/>
+          <a:chOff x="0" y="0"/>
+          <a:chExt cx="0" cy="0"/>
+        </a:xfrm>
+      </p:grpSpPr>
+      <p:sp>
+        <p:nvSpPr>
+          <p:cNvPr id="7" name="Title 6">
+            <a:extLst>
+              <a:ext uri="{FF2B5EF4-FFF2-40B4-BE49-F238E27FC236}">
+                <a16:creationId xmlns:a16="http://schemas.microsoft.com/office/drawing/2014/main" id="{92E4C6C6-5D37-EC74-9D77-34ADE0B9875A}"/>
+              </a:ext>
+            </a:extLst>
+          </p:cNvPr>
+          <p:cNvSpPr>
+            <a:spLocks noGrp="1"/>
+          </p:cNvSpPr>
+          <p:nvPr>
+            <p:ph type="title"/>
+          </p:nvPr>
+        </p:nvSpPr>
+        <p:spPr/>
+        <p:txBody>
+          <a:bodyPr>
+            <a:normAutofit fontScale="90000"/>
+          </a:bodyPr>
+          <a:lstStyle/>
+          <a:p>
+            <a:r>
+              <a:rPr lang="en-US" dirty="0"/>
+              <a:t>Today </a:t>
+            </a:r>
+          </a:p>
+        </p:txBody>
+      </p:sp>
+      <p:sp>
+        <p:nvSpPr>
+          <p:cNvPr id="8" name="Text Placeholder 7">
+            <a:extLst>
+              <a:ext uri="{FF2B5EF4-FFF2-40B4-BE49-F238E27FC236}">
+                <a16:creationId xmlns:a16="http://schemas.microsoft.com/office/drawing/2014/main" id="{EE484ACB-E931-F921-E13D-585FE1118A7A}"/>
+              </a:ext>
+            </a:extLst>
+          </p:cNvPr>
+          <p:cNvSpPr>
+            <a:spLocks noGrp="1"/>
+          </p:cNvSpPr>
+          <p:nvPr>
+            <p:ph type="body" idx="1"/>
+          </p:nvPr>
+        </p:nvSpPr>
+        <p:spPr>
+          <a:xfrm>
+            <a:off x="952500" y="1409700"/>
+            <a:ext cx="11099800" cy="3736458"/>
+          </a:xfrm>
+        </p:spPr>
+        <p:txBody>
+          <a:bodyPr/>
+          <a:lstStyle/>
+          <a:p>
+            <a:r>
+              <a:rPr lang="en-US" dirty="0"/>
+              <a:t>Today’s </a:t>
+            </a:r>
+            <a:r>
+              <a:rPr lang="en-US" dirty="0" err="1"/>
+              <a:t>excercises</a:t>
+            </a:r>
+            <a:r>
+              <a:rPr lang="en-US" dirty="0"/>
+              <a:t> are intended to be light touch and mainly provide introduction to the environment and ensure technology is working. </a:t>
+            </a:r>
+          </a:p>
+        </p:txBody>
+      </p:sp>
+      <p:pic>
+        <p:nvPicPr>
+          <p:cNvPr id="5" name="Google Shape;104;p19">
+            <a:extLst>
+              <a:ext uri="{FF2B5EF4-FFF2-40B4-BE49-F238E27FC236}">
+                <a16:creationId xmlns:a16="http://schemas.microsoft.com/office/drawing/2014/main" id="{D296BCEC-73CF-AE20-FD5E-577FC3A3860A}"/>
+              </a:ext>
+            </a:extLst>
+          </p:cNvPr>
+          <p:cNvPicPr preferRelativeResize="0"/>
+          <p:nvPr/>
+        </p:nvPicPr>
+        <p:blipFill>
+          <a:blip r:embed="rId3">
+            <a:alphaModFix/>
+          </a:blip>
+          <a:stretch>
+            <a:fillRect/>
+          </a:stretch>
+        </p:blipFill>
+        <p:spPr>
+          <a:xfrm>
+            <a:off x="952500" y="3937284"/>
             <a:ext cx="3098966" cy="2772256"/>
           </a:xfrm>
           <a:prstGeom prst="rect">
@@ -15434,7 +16527,7 @@
           <p:cNvPr id="6" name="Graphic 5">
             <a:extLst>
               <a:ext uri="{FF2B5EF4-FFF2-40B4-BE49-F238E27FC236}">
-                <a16:creationId xmlns:a16="http://schemas.microsoft.com/office/drawing/2014/main" id="{BD33E835-BDF2-264C-BB4E-9A0EB7A6C956}"/>
+                <a16:creationId xmlns:a16="http://schemas.microsoft.com/office/drawing/2014/main" id="{A5DD4D0F-8FF4-F16D-BA8A-9F6C73B69991}"/>
               </a:ext>
             </a:extLst>
           </p:cNvPr>
@@ -15450,7 +16543,7 @@
                 <a14:useLocalDpi xmlns:a14="http://schemas.microsoft.com/office/drawing/2010/main" val="0"/>
               </a:ext>
               <a:ext uri="{96DAC541-7B7A-43D3-8B79-37D633B846F1}">
-                <asvg:svgBlip xmlns:asvg="http://schemas.microsoft.com/office/drawing/2016/SVG/main" r:embed="rId3"/>
+                <asvg:svgBlip xmlns:asvg="http://schemas.microsoft.com/office/drawing/2016/SVG/main" r:embed="rId4"/>
               </a:ext>
             </a:extLst>
           </a:blip>
@@ -15460,7 +16553,7 @@
         </p:blipFill>
         <p:spPr>
           <a:xfrm>
-            <a:off x="7524723" y="6159500"/>
+            <a:off x="5050284" y="3937284"/>
             <a:ext cx="2806212" cy="3231395"/>
           </a:xfrm>
           <a:prstGeom prst="rect">
@@ -15468,10 +16561,146 @@
           </a:prstGeom>
         </p:spPr>
       </p:pic>
+      <p:pic>
+        <p:nvPicPr>
+          <p:cNvPr id="2" name="Google Shape;111;p20">
+            <a:extLst>
+              <a:ext uri="{FF2B5EF4-FFF2-40B4-BE49-F238E27FC236}">
+                <a16:creationId xmlns:a16="http://schemas.microsoft.com/office/drawing/2014/main" id="{81E0C3A0-986F-B517-DF99-33B8782AC62F}"/>
+              </a:ext>
+            </a:extLst>
+          </p:cNvPr>
+          <p:cNvPicPr preferRelativeResize="0"/>
+          <p:nvPr/>
+        </p:nvPicPr>
+        <p:blipFill>
+          <a:blip r:embed="rId5">
+            <a:alphaModFix/>
+          </a:blip>
+          <a:stretch>
+            <a:fillRect/>
+          </a:stretch>
+        </p:blipFill>
+        <p:spPr>
+          <a:xfrm>
+            <a:off x="926798" y="6058125"/>
+            <a:ext cx="4123486" cy="1666560"/>
+          </a:xfrm>
+          <a:prstGeom prst="rect">
+            <a:avLst/>
+          </a:prstGeom>
+          <a:noFill/>
+          <a:ln>
+            <a:noFill/>
+          </a:ln>
+        </p:spPr>
+      </p:pic>
+      <p:pic>
+        <p:nvPicPr>
+          <p:cNvPr id="3" name="Google Shape;112;p20">
+            <a:extLst>
+              <a:ext uri="{FF2B5EF4-FFF2-40B4-BE49-F238E27FC236}">
+                <a16:creationId xmlns:a16="http://schemas.microsoft.com/office/drawing/2014/main" id="{0587EB92-F92B-214A-ED2F-2B53D12E16ED}"/>
+              </a:ext>
+            </a:extLst>
+          </p:cNvPr>
+          <p:cNvPicPr preferRelativeResize="0"/>
+          <p:nvPr/>
+        </p:nvPicPr>
+        <p:blipFill>
+          <a:blip r:embed="rId6">
+            <a:alphaModFix/>
+          </a:blip>
+          <a:stretch>
+            <a:fillRect/>
+          </a:stretch>
+        </p:blipFill>
+        <p:spPr>
+          <a:xfrm>
+            <a:off x="7667065" y="6275459"/>
+            <a:ext cx="4123486" cy="989619"/>
+          </a:xfrm>
+          <a:prstGeom prst="rect">
+            <a:avLst/>
+          </a:prstGeom>
+          <a:noFill/>
+          <a:ln>
+            <a:noFill/>
+          </a:ln>
+        </p:spPr>
+      </p:pic>
+      <p:pic>
+        <p:nvPicPr>
+          <p:cNvPr id="4" name="Google Shape;113;p20">
+            <a:extLst>
+              <a:ext uri="{FF2B5EF4-FFF2-40B4-BE49-F238E27FC236}">
+                <a16:creationId xmlns:a16="http://schemas.microsoft.com/office/drawing/2014/main" id="{423CF6D5-A39D-7C9E-2415-D707375EA120}"/>
+              </a:ext>
+            </a:extLst>
+          </p:cNvPr>
+          <p:cNvPicPr preferRelativeResize="0"/>
+          <p:nvPr/>
+        </p:nvPicPr>
+        <p:blipFill>
+          <a:blip r:embed="rId7">
+            <a:alphaModFix/>
+          </a:blip>
+          <a:stretch>
+            <a:fillRect/>
+          </a:stretch>
+        </p:blipFill>
+        <p:spPr>
+          <a:xfrm>
+            <a:off x="1946354" y="7673742"/>
+            <a:ext cx="4210223" cy="1666560"/>
+          </a:xfrm>
+          <a:prstGeom prst="rect">
+            <a:avLst/>
+          </a:prstGeom>
+          <a:noFill/>
+          <a:ln>
+            <a:noFill/>
+          </a:ln>
+        </p:spPr>
+      </p:pic>
+      <p:pic>
+        <p:nvPicPr>
+          <p:cNvPr id="9" name="Google Shape;149;p24">
+            <a:extLst>
+              <a:ext uri="{FF2B5EF4-FFF2-40B4-BE49-F238E27FC236}">
+                <a16:creationId xmlns:a16="http://schemas.microsoft.com/office/drawing/2014/main" id="{D8D166FD-8B31-54C4-9989-DA88BCA830D6}"/>
+              </a:ext>
+            </a:extLst>
+          </p:cNvPr>
+          <p:cNvPicPr preferRelativeResize="0"/>
+          <p:nvPr/>
+        </p:nvPicPr>
+        <p:blipFill>
+          <a:blip r:embed="rId8">
+            <a:alphaModFix/>
+          </a:blip>
+          <a:stretch>
+            <a:fillRect/>
+          </a:stretch>
+        </p:blipFill>
+        <p:spPr>
+          <a:xfrm>
+            <a:off x="7176133" y="7386590"/>
+            <a:ext cx="3733120" cy="2009636"/>
+          </a:xfrm>
+          <a:prstGeom prst="rect">
+            <a:avLst/>
+          </a:prstGeom>
+          <a:noFill/>
+          <a:ln>
+            <a:noFill/>
+          </a:ln>
+        </p:spPr>
+      </p:pic>
     </p:spTree>
     <p:extLst>
       <p:ext uri="{BB962C8B-B14F-4D97-AF65-F5344CB8AC3E}">
-        <p14:creationId xmlns:p14="http://schemas.microsoft.com/office/powerpoint/2010/main" val="3044921591"/>
+        <p14:creationId xmlns:p14="http://schemas.microsoft.com/office/powerpoint/2010/main" val="3266445502"/>
       </p:ext>
     </p:extLst>
   </p:cSld>
@@ -15551,29 +16780,19 @@
           <a:lstStyle/>
           <a:p>
             <a:r>
-              <a:rPr lang="en-US" dirty="0"/>
-              <a:t>2 assessments. </a:t>
-            </a:r>
-          </a:p>
-          <a:p>
-            <a:r>
               <a:rPr lang="en-GB" dirty="0"/>
-              <a:t>Programming </a:t>
+              <a:t>Programming exercise will be a set of problems for you to answer.  These will be submitted as a “</a:t>
             </a:r>
             <a:r>
               <a:rPr lang="en-GB" dirty="0" err="1"/>
-              <a:t>excercise</a:t>
+              <a:t>Jupyter</a:t>
             </a:r>
             <a:r>
               <a:rPr lang="en-GB" dirty="0"/>
-              <a:t>: 25% due Thursday 1pm, week 7</a:t>
-            </a:r>
-          </a:p>
-          <a:p>
-            <a:r>
-              <a:rPr lang="en-GB" dirty="0"/>
-              <a:t>Final Project: 75%, Thursday, 1pm,  week 11 </a:t>
-            </a:r>
+              <a:t> Notebook” (We will introduce these this week)</a:t>
+            </a:r>
+          </a:p>
+          <a:p>
             <a:endParaRPr lang="en-US" dirty="0"/>
           </a:p>
         </p:txBody>
@@ -15581,7 +16800,351 @@
     </p:spTree>
     <p:extLst>
       <p:ext uri="{BB962C8B-B14F-4D97-AF65-F5344CB8AC3E}">
-        <p14:creationId xmlns:p14="http://schemas.microsoft.com/office/powerpoint/2010/main" val="1917384157"/>
+        <p14:creationId xmlns:p14="http://schemas.microsoft.com/office/powerpoint/2010/main" val="588310735"/>
+      </p:ext>
+    </p:extLst>
+  </p:cSld>
+  <p:clrMapOvr>
+    <a:masterClrMapping/>
+  </p:clrMapOvr>
+  <p:transition spd="med"/>
+</p:sld>
+</file>
+
+<file path=ppt/slides/slide30.xml><?xml version="1.0" encoding="utf-8"?>
+<p:sld xmlns:a="http://schemas.openxmlformats.org/drawingml/2006/main" xmlns:r="http://schemas.openxmlformats.org/officeDocument/2006/relationships" xmlns:p="http://schemas.openxmlformats.org/presentationml/2006/main">
+  <p:cSld>
+    <p:spTree>
+      <p:nvGrpSpPr>
+        <p:cNvPr id="1" name=""/>
+        <p:cNvGrpSpPr/>
+        <p:nvPr/>
+      </p:nvGrpSpPr>
+      <p:grpSpPr>
+        <a:xfrm>
+          <a:off x="0" y="0"/>
+          <a:ext cx="0" cy="0"/>
+          <a:chOff x="0" y="0"/>
+          <a:chExt cx="0" cy="0"/>
+        </a:xfrm>
+      </p:grpSpPr>
+      <p:sp>
+        <p:nvSpPr>
+          <p:cNvPr id="2" name="Title 1">
+            <a:extLst>
+              <a:ext uri="{FF2B5EF4-FFF2-40B4-BE49-F238E27FC236}">
+                <a16:creationId xmlns:a16="http://schemas.microsoft.com/office/drawing/2014/main" id="{721877CD-EBBE-7997-7663-B2E08F85CDDF}"/>
+              </a:ext>
+            </a:extLst>
+          </p:cNvPr>
+          <p:cNvSpPr>
+            <a:spLocks noGrp="1"/>
+          </p:cNvSpPr>
+          <p:nvPr>
+            <p:ph type="title"/>
+          </p:nvPr>
+        </p:nvSpPr>
+        <p:spPr>
+          <a:xfrm>
+            <a:off x="105867" y="176711"/>
+            <a:ext cx="11099800" cy="1080046"/>
+          </a:xfrm>
+        </p:spPr>
+        <p:txBody>
+          <a:bodyPr>
+            <a:normAutofit/>
+          </a:bodyPr>
+          <a:lstStyle/>
+          <a:p>
+            <a:r>
+              <a:rPr lang="en-US" sz="6000" dirty="0"/>
+              <a:t>Jupyter – Literate Computing</a:t>
+            </a:r>
+          </a:p>
+        </p:txBody>
+      </p:sp>
+      <p:sp>
+        <p:nvSpPr>
+          <p:cNvPr id="3" name="Text Placeholder 2">
+            <a:extLst>
+              <a:ext uri="{FF2B5EF4-FFF2-40B4-BE49-F238E27FC236}">
+                <a16:creationId xmlns:a16="http://schemas.microsoft.com/office/drawing/2014/main" id="{76F81658-46C3-81BC-5910-894BDAC515B6}"/>
+              </a:ext>
+            </a:extLst>
+          </p:cNvPr>
+          <p:cNvSpPr>
+            <a:spLocks noGrp="1"/>
+          </p:cNvSpPr>
+          <p:nvPr>
+            <p:ph type="body" idx="1"/>
+          </p:nvPr>
+        </p:nvSpPr>
+        <p:spPr>
+          <a:xfrm>
+            <a:off x="952499" y="1409700"/>
+            <a:ext cx="11870871" cy="8039100"/>
+          </a:xfrm>
+        </p:spPr>
+        <p:txBody>
+          <a:bodyPr>
+            <a:normAutofit/>
+          </a:bodyPr>
+          <a:lstStyle/>
+          <a:p>
+            <a:r>
+              <a:rPr lang="en-GB" dirty="0"/>
+              <a:t>Jupyter notebooks combine executable code, code outputs, and text into one connected file. </a:t>
+            </a:r>
+          </a:p>
+          <a:p>
+            <a:r>
+              <a:rPr lang="en-GB" dirty="0"/>
+              <a:t>It is a very powerful paradigm that we will be using the entire term. </a:t>
+            </a:r>
+          </a:p>
+          <a:p>
+            <a:r>
+              <a:rPr lang="en-GB" dirty="0"/>
+              <a:t>Rather than organizing code solely for the computer’s execution of the code, </a:t>
+            </a:r>
+            <a:r>
+              <a:rPr lang="en-GB" b="1" u="sng" dirty="0"/>
+              <a:t>literate programming </a:t>
+            </a:r>
+            <a:r>
+              <a:rPr lang="en-GB" dirty="0"/>
+              <a:t>treats a program as literature understandable to human beings, prioritizing the programmer’s own thought process.</a:t>
+            </a:r>
+          </a:p>
+          <a:p>
+            <a:r>
+              <a:rPr lang="en-GB" dirty="0">
+                <a:hlinkClick r:id="rId3"/>
+              </a:rPr>
+              <a:t>https://programminghistorian.org/en/lessons/jupyter-notebooks</a:t>
+            </a:r>
+            <a:endParaRPr lang="en-GB" dirty="0"/>
+          </a:p>
+        </p:txBody>
+      </p:sp>
+      <p:sp>
+        <p:nvSpPr>
+          <p:cNvPr id="6" name="TextBox 5">
+            <a:extLst>
+              <a:ext uri="{FF2B5EF4-FFF2-40B4-BE49-F238E27FC236}">
+                <a16:creationId xmlns:a16="http://schemas.microsoft.com/office/drawing/2014/main" id="{3A9A9C6C-4160-A75E-EC54-251DEE706178}"/>
+              </a:ext>
+            </a:extLst>
+          </p:cNvPr>
+          <p:cNvSpPr txBox="1"/>
+          <p:nvPr/>
+        </p:nvSpPr>
+        <p:spPr>
+          <a:xfrm>
+            <a:off x="5391529" y="8380276"/>
+            <a:ext cx="102657" cy="656590"/>
+          </a:xfrm>
+          <a:prstGeom prst="rect">
+            <a:avLst/>
+          </a:prstGeom>
+          <a:noFill/>
+          <a:ln w="12700" cap="flat">
+            <a:noFill/>
+            <a:miter lim="400000"/>
+          </a:ln>
+          <a:effectLst/>
+          <a:sp3d/>
+        </p:spPr>
+        <p:style>
+          <a:lnRef idx="0">
+            <a:scrgbClr r="0" g="0" b="0"/>
+          </a:lnRef>
+          <a:fillRef idx="0">
+            <a:scrgbClr r="0" g="0" b="0"/>
+          </a:fillRef>
+          <a:effectRef idx="0">
+            <a:scrgbClr r="0" g="0" b="0"/>
+          </a:effectRef>
+          <a:fontRef idx="none"/>
+        </p:style>
+        <p:txBody>
+          <a:bodyPr rot="0" spcFirstLastPara="1" vertOverflow="overflow" horzOverflow="overflow" vert="horz" wrap="none" lIns="50800" tIns="50800" rIns="50800" bIns="50800" numCol="1" spcCol="38100" rtlCol="0" anchor="ctr">
+            <a:spAutoFit/>
+          </a:bodyPr>
+          <a:lstStyle/>
+          <a:p>
+            <a:pPr marL="0" marR="0" indent="0" algn="ctr" defTabSz="584200" rtl="0" fontAlgn="auto" latinLnBrk="0" hangingPunct="0">
+              <a:lnSpc>
+                <a:spcPct val="100000"/>
+              </a:lnSpc>
+              <a:spcBef>
+                <a:spcPts val="0"/>
+              </a:spcBef>
+              <a:spcAft>
+                <a:spcPts val="0"/>
+              </a:spcAft>
+              <a:buClrTx/>
+              <a:buSzTx/>
+              <a:buFontTx/>
+              <a:buNone/>
+              <a:tabLst/>
+            </a:pPr>
+            <a:endParaRPr kumimoji="0" lang="en-US" sz="3600" b="0" i="0" u="none" strike="noStrike" cap="none" spc="0" normalizeH="0" baseline="0" dirty="0">
+              <a:ln>
+                <a:noFill/>
+              </a:ln>
+              <a:solidFill>
+                <a:srgbClr val="000000"/>
+              </a:solidFill>
+              <a:effectLst/>
+              <a:uFillTx/>
+              <a:latin typeface="+mn-lt"/>
+              <a:ea typeface="+mn-ea"/>
+              <a:cs typeface="+mn-cs"/>
+              <a:sym typeface="Helvetica Light"/>
+            </a:endParaRPr>
+          </a:p>
+        </p:txBody>
+      </p:sp>
+      <p:pic>
+        <p:nvPicPr>
+          <p:cNvPr id="7" name="Graphic 6">
+            <a:extLst>
+              <a:ext uri="{FF2B5EF4-FFF2-40B4-BE49-F238E27FC236}">
+                <a16:creationId xmlns:a16="http://schemas.microsoft.com/office/drawing/2014/main" id="{090A7902-D467-953F-A573-7647D031F7F6}"/>
+              </a:ext>
+            </a:extLst>
+          </p:cNvPr>
+          <p:cNvPicPr>
+            <a:picLocks noChangeAspect="1"/>
+          </p:cNvPicPr>
+          <p:nvPr/>
+        </p:nvPicPr>
+        <p:blipFill>
+          <a:blip>
+            <a:extLst>
+              <a:ext uri="{28A0092B-C50C-407E-A947-70E740481C1C}">
+                <a14:useLocalDpi xmlns:a14="http://schemas.microsoft.com/office/drawing/2010/main" val="0"/>
+              </a:ext>
+              <a:ext uri="{96DAC541-7B7A-43D3-8B79-37D633B846F1}">
+                <asvg:svgBlip xmlns:asvg="http://schemas.microsoft.com/office/drawing/2016/SVG/main" r:embed="rId4"/>
+              </a:ext>
+            </a:extLst>
+          </a:blip>
+          <a:stretch>
+            <a:fillRect/>
+          </a:stretch>
+        </p:blipFill>
+        <p:spPr>
+          <a:xfrm>
+            <a:off x="11135562" y="0"/>
+            <a:ext cx="1687808" cy="1943536"/>
+          </a:xfrm>
+          <a:prstGeom prst="rect">
+            <a:avLst/>
+          </a:prstGeom>
+        </p:spPr>
+      </p:pic>
+    </p:spTree>
+    <p:extLst>
+      <p:ext uri="{BB962C8B-B14F-4D97-AF65-F5344CB8AC3E}">
+        <p14:creationId xmlns:p14="http://schemas.microsoft.com/office/powerpoint/2010/main" val="3850460150"/>
+      </p:ext>
+    </p:extLst>
+  </p:cSld>
+  <p:clrMapOvr>
+    <a:masterClrMapping/>
+  </p:clrMapOvr>
+  <p:transition spd="med"/>
+</p:sld>
+</file>
+
+<file path=ppt/slides/slide31.xml><?xml version="1.0" encoding="utf-8"?>
+<p:sld xmlns:a="http://schemas.openxmlformats.org/drawingml/2006/main" xmlns:r="http://schemas.openxmlformats.org/officeDocument/2006/relationships" xmlns:p="http://schemas.openxmlformats.org/presentationml/2006/main">
+  <p:cSld>
+    <p:spTree>
+      <p:nvGrpSpPr>
+        <p:cNvPr id="1" name="">
+          <a:extLst>
+            <a:ext uri="{FF2B5EF4-FFF2-40B4-BE49-F238E27FC236}">
+              <a16:creationId xmlns:a16="http://schemas.microsoft.com/office/drawing/2014/main" id="{E3E53B1D-0370-3E11-1AE5-8965EA2CDDD5}"/>
+            </a:ext>
+          </a:extLst>
+        </p:cNvPr>
+        <p:cNvGrpSpPr/>
+        <p:nvPr/>
+      </p:nvGrpSpPr>
+      <p:grpSpPr>
+        <a:xfrm>
+          <a:off x="0" y="0"/>
+          <a:ext cx="0" cy="0"/>
+          <a:chOff x="0" y="0"/>
+          <a:chExt cx="0" cy="0"/>
+        </a:xfrm>
+      </p:grpSpPr>
+      <p:sp>
+        <p:nvSpPr>
+          <p:cNvPr id="4" name="Title 3">
+            <a:extLst>
+              <a:ext uri="{FF2B5EF4-FFF2-40B4-BE49-F238E27FC236}">
+                <a16:creationId xmlns:a16="http://schemas.microsoft.com/office/drawing/2014/main" id="{4FD15DA2-0344-6618-2854-B4D9F5400B8D}"/>
+              </a:ext>
+            </a:extLst>
+          </p:cNvPr>
+          <p:cNvSpPr>
+            <a:spLocks noGrp="1"/>
+          </p:cNvSpPr>
+          <p:nvPr>
+            <p:ph type="title"/>
+          </p:nvPr>
+        </p:nvSpPr>
+        <p:spPr/>
+        <p:txBody>
+          <a:bodyPr>
+            <a:normAutofit fontScale="90000"/>
+          </a:bodyPr>
+          <a:lstStyle/>
+          <a:p>
+            <a:r>
+              <a:rPr lang="en-US" dirty="0"/>
+              <a:t>Python and Jupyter Demo</a:t>
+            </a:r>
+            <a:br>
+              <a:rPr lang="en-US" dirty="0"/>
+            </a:br>
+            <a:endParaRPr lang="en-US" dirty="0"/>
+          </a:p>
+        </p:txBody>
+      </p:sp>
+      <p:sp>
+        <p:nvSpPr>
+          <p:cNvPr id="6" name="Text Placeholder 5">
+            <a:extLst>
+              <a:ext uri="{FF2B5EF4-FFF2-40B4-BE49-F238E27FC236}">
+                <a16:creationId xmlns:a16="http://schemas.microsoft.com/office/drawing/2014/main" id="{33B687A2-20CD-286F-FEDD-0FDACA587855}"/>
+              </a:ext>
+            </a:extLst>
+          </p:cNvPr>
+          <p:cNvSpPr>
+            <a:spLocks noGrp="1"/>
+          </p:cNvSpPr>
+          <p:nvPr>
+            <p:ph type="body" sz="quarter" idx="1"/>
+          </p:nvPr>
+        </p:nvSpPr>
+        <p:spPr/>
+        <p:txBody>
+          <a:bodyPr/>
+          <a:lstStyle/>
+          <a:p>
+            <a:endParaRPr lang="en-US"/>
+          </a:p>
+        </p:txBody>
+      </p:sp>
+    </p:spTree>
+    <p:extLst>
+      <p:ext uri="{BB962C8B-B14F-4D97-AF65-F5344CB8AC3E}">
+        <p14:creationId xmlns:p14="http://schemas.microsoft.com/office/powerpoint/2010/main" val="3989770285"/>
       </p:ext>
     </p:extLst>
   </p:cSld>
@@ -15633,106 +17196,6 @@
           <a:lstStyle/>
           <a:p>
             <a:r>
-              <a:rPr lang="en-US" dirty="0"/>
-              <a:t>Assessments</a:t>
-            </a:r>
-          </a:p>
-        </p:txBody>
-      </p:sp>
-      <p:sp>
-        <p:nvSpPr>
-          <p:cNvPr id="10" name="Text Placeholder 9">
-            <a:extLst>
-              <a:ext uri="{FF2B5EF4-FFF2-40B4-BE49-F238E27FC236}">
-                <a16:creationId xmlns:a16="http://schemas.microsoft.com/office/drawing/2014/main" id="{F65DCA9F-D82A-9C43-8E1D-AFD3DF9E2401}"/>
-              </a:ext>
-            </a:extLst>
-          </p:cNvPr>
-          <p:cNvSpPr>
-            <a:spLocks noGrp="1"/>
-          </p:cNvSpPr>
-          <p:nvPr>
-            <p:ph type="body" idx="1"/>
-          </p:nvPr>
-        </p:nvSpPr>
-        <p:spPr/>
-        <p:txBody>
-          <a:bodyPr/>
-          <a:lstStyle/>
-          <a:p>
-            <a:r>
-              <a:rPr lang="en-GB" dirty="0"/>
-              <a:t>Programming exercise will be a set of problems for you to answer.  These will be submitted as a “</a:t>
-            </a:r>
-            <a:r>
-              <a:rPr lang="en-GB" dirty="0" err="1"/>
-              <a:t>Jupyter</a:t>
-            </a:r>
-            <a:r>
-              <a:rPr lang="en-GB" dirty="0"/>
-              <a:t> Notebook” (We will introduce these this week)</a:t>
-            </a:r>
-          </a:p>
-          <a:p>
-            <a:endParaRPr lang="en-US" dirty="0"/>
-          </a:p>
-        </p:txBody>
-      </p:sp>
-    </p:spTree>
-    <p:extLst>
-      <p:ext uri="{BB962C8B-B14F-4D97-AF65-F5344CB8AC3E}">
-        <p14:creationId xmlns:p14="http://schemas.microsoft.com/office/powerpoint/2010/main" val="588310735"/>
-      </p:ext>
-    </p:extLst>
-  </p:cSld>
-  <p:clrMapOvr>
-    <a:masterClrMapping/>
-  </p:clrMapOvr>
-  <p:transition spd="med"/>
-</p:sld>
-</file>
-
-<file path=ppt/slides/slide5.xml><?xml version="1.0" encoding="utf-8"?>
-<p:sld xmlns:a="http://schemas.openxmlformats.org/drawingml/2006/main" xmlns:r="http://schemas.openxmlformats.org/officeDocument/2006/relationships" xmlns:p="http://schemas.openxmlformats.org/presentationml/2006/main">
-  <p:cSld>
-    <p:spTree>
-      <p:nvGrpSpPr>
-        <p:cNvPr id="1" name=""/>
-        <p:cNvGrpSpPr/>
-        <p:nvPr/>
-      </p:nvGrpSpPr>
-      <p:grpSpPr>
-        <a:xfrm>
-          <a:off x="0" y="0"/>
-          <a:ext cx="0" cy="0"/>
-          <a:chOff x="0" y="0"/>
-          <a:chExt cx="0" cy="0"/>
-        </a:xfrm>
-      </p:grpSpPr>
-      <p:sp>
-        <p:nvSpPr>
-          <p:cNvPr id="9" name="Title 8">
-            <a:extLst>
-              <a:ext uri="{FF2B5EF4-FFF2-40B4-BE49-F238E27FC236}">
-                <a16:creationId xmlns:a16="http://schemas.microsoft.com/office/drawing/2014/main" id="{7FE4D6C6-66B8-9044-AC75-FA288B4AA0C5}"/>
-              </a:ext>
-            </a:extLst>
-          </p:cNvPr>
-          <p:cNvSpPr>
-            <a:spLocks noGrp="1"/>
-          </p:cNvSpPr>
-          <p:nvPr>
-            <p:ph type="title"/>
-          </p:nvPr>
-        </p:nvSpPr>
-        <p:spPr/>
-        <p:txBody>
-          <a:bodyPr>
-            <a:normAutofit fontScale="90000"/>
-          </a:bodyPr>
-          <a:lstStyle/>
-          <a:p>
-            <a:r>
               <a:rPr lang="en-GB" dirty="0"/>
               <a:t>Final Project</a:t>
             </a:r>
@@ -15885,7 +17348,7 @@
 </p:sld>
 </file>
 
-<file path=ppt/slides/slide6.xml><?xml version="1.0" encoding="utf-8"?>
+<file path=ppt/slides/slide5.xml><?xml version="1.0" encoding="utf-8"?>
 <p:sld xmlns:a="http://schemas.openxmlformats.org/drawingml/2006/main" xmlns:r="http://schemas.openxmlformats.org/officeDocument/2006/relationships" xmlns:p="http://schemas.openxmlformats.org/presentationml/2006/main">
   <p:cSld>
     <p:spTree>
@@ -15989,7 +17452,7 @@
 </p:sld>
 </file>
 
-<file path=ppt/slides/slide7.xml><?xml version="1.0" encoding="utf-8"?>
+<file path=ppt/slides/slide6.xml><?xml version="1.0" encoding="utf-8"?>
 <p:sld xmlns:a="http://schemas.openxmlformats.org/drawingml/2006/main" xmlns:r="http://schemas.openxmlformats.org/officeDocument/2006/relationships" xmlns:p="http://schemas.openxmlformats.org/presentationml/2006/main">
   <p:cSld>
     <p:spTree>
@@ -16093,7 +17556,7 @@
 </p:sld>
 </file>
 
-<file path=ppt/slides/slide8.xml><?xml version="1.0" encoding="utf-8"?>
+<file path=ppt/slides/slide7.xml><?xml version="1.0" encoding="utf-8"?>
 <p:sld xmlns:a="http://schemas.openxmlformats.org/drawingml/2006/main" xmlns:r="http://schemas.openxmlformats.org/officeDocument/2006/relationships" xmlns:p="http://schemas.openxmlformats.org/presentationml/2006/main">
   <p:cSld>
     <p:spTree>
@@ -16194,7 +17657,7 @@
 </p:sld>
 </file>
 
-<file path=ppt/slides/slide9.xml><?xml version="1.0" encoding="utf-8"?>
+<file path=ppt/slides/slide8.xml><?xml version="1.0" encoding="utf-8"?>
 <p:sld xmlns:a="http://schemas.openxmlformats.org/drawingml/2006/main" xmlns:r="http://schemas.openxmlformats.org/officeDocument/2006/relationships" xmlns:p="http://schemas.openxmlformats.org/presentationml/2006/main">
   <p:cSld>
     <p:spTree>
@@ -16288,6 +17751,136 @@
     <p:extLst>
       <p:ext uri="{BB962C8B-B14F-4D97-AF65-F5344CB8AC3E}">
         <p14:creationId xmlns:p14="http://schemas.microsoft.com/office/powerpoint/2010/main" val="508855193"/>
+      </p:ext>
+    </p:extLst>
+  </p:cSld>
+  <p:clrMapOvr>
+    <a:masterClrMapping/>
+  </p:clrMapOvr>
+  <p:transition spd="med"/>
+</p:sld>
+</file>
+
+<file path=ppt/slides/slide9.xml><?xml version="1.0" encoding="utf-8"?>
+<p:sld xmlns:a="http://schemas.openxmlformats.org/drawingml/2006/main" xmlns:r="http://schemas.openxmlformats.org/officeDocument/2006/relationships" xmlns:p="http://schemas.openxmlformats.org/presentationml/2006/main">
+  <p:cSld>
+    <p:spTree>
+      <p:nvGrpSpPr>
+        <p:cNvPr id="1" name=""/>
+        <p:cNvGrpSpPr/>
+        <p:nvPr/>
+      </p:nvGrpSpPr>
+      <p:grpSpPr>
+        <a:xfrm>
+          <a:off x="0" y="0"/>
+          <a:ext cx="0" cy="0"/>
+          <a:chOff x="0" y="0"/>
+          <a:chExt cx="0" cy="0"/>
+        </a:xfrm>
+      </p:grpSpPr>
+      <p:sp>
+        <p:nvSpPr>
+          <p:cNvPr id="2" name="Title 1">
+            <a:extLst>
+              <a:ext uri="{FF2B5EF4-FFF2-40B4-BE49-F238E27FC236}">
+                <a16:creationId xmlns:a16="http://schemas.microsoft.com/office/drawing/2014/main" id="{5E912C88-7968-0C49-2122-4BD5988A61D0}"/>
+              </a:ext>
+            </a:extLst>
+          </p:cNvPr>
+          <p:cNvSpPr>
+            <a:spLocks noGrp="1"/>
+          </p:cNvSpPr>
+          <p:nvPr>
+            <p:ph type="title"/>
+          </p:nvPr>
+        </p:nvSpPr>
+        <p:spPr/>
+        <p:txBody>
+          <a:bodyPr>
+            <a:normAutofit fontScale="90000"/>
+          </a:bodyPr>
+          <a:lstStyle/>
+          <a:p>
+            <a:endParaRPr lang="en-US"/>
+          </a:p>
+        </p:txBody>
+      </p:sp>
+      <p:sp>
+        <p:nvSpPr>
+          <p:cNvPr id="3" name="Text Placeholder 2">
+            <a:extLst>
+              <a:ext uri="{FF2B5EF4-FFF2-40B4-BE49-F238E27FC236}">
+                <a16:creationId xmlns:a16="http://schemas.microsoft.com/office/drawing/2014/main" id="{10B538AC-6CAE-4D52-C6E9-51DE03A90500}"/>
+              </a:ext>
+            </a:extLst>
+          </p:cNvPr>
+          <p:cNvSpPr>
+            <a:spLocks noGrp="1"/>
+          </p:cNvSpPr>
+          <p:nvPr>
+            <p:ph type="body" idx="1"/>
+          </p:nvPr>
+        </p:nvSpPr>
+        <p:spPr/>
+        <p:txBody>
+          <a:bodyPr>
+            <a:normAutofit fontScale="92500" lnSpcReduction="10000"/>
+          </a:bodyPr>
+          <a:lstStyle/>
+          <a:p>
+            <a:r>
+              <a:rPr lang="en-GB" dirty="0">
+                <a:hlinkClick r:id="rId2" tooltip="View other papers by this author"/>
+              </a:rPr>
+              <a:t>David Stromberg</a:t>
+            </a:r>
+            <a:endParaRPr lang="en-GB" dirty="0"/>
+          </a:p>
+          <a:p>
+            <a:r>
+              <a:rPr lang="en-GB" dirty="0"/>
+              <a:t>Stockholm University</a:t>
+            </a:r>
+          </a:p>
+          <a:p>
+            <a:r>
+              <a:rPr lang="en-GB" dirty="0">
+                <a:hlinkClick r:id="rId3" tooltip="View other papers by this author"/>
+              </a:rPr>
+              <a:t>Victor Lei</a:t>
+            </a:r>
+            <a:endParaRPr lang="en-GB" dirty="0"/>
+          </a:p>
+          <a:p>
+            <a:r>
+              <a:rPr lang="en-GB" dirty="0"/>
+              <a:t>The University of Hong Kong - University of Hong Kong</a:t>
+            </a:r>
+          </a:p>
+          <a:p>
+            <a:r>
+              <a:rPr lang="en-GB" dirty="0">
+                <a:hlinkClick r:id="rId4" tooltip="View other papers by this author"/>
+              </a:rPr>
+              <a:t>Yanhui Wu</a:t>
+            </a:r>
+            <a:endParaRPr lang="en-GB" dirty="0"/>
+          </a:p>
+          <a:p>
+            <a:r>
+              <a:rPr lang="en-GB" dirty="0"/>
+              <a:t>University of Hong Kong; Centre for Economic Policy Research (CEPR)</a:t>
+            </a:r>
+          </a:p>
+          <a:p>
+            <a:endParaRPr lang="en-US" dirty="0"/>
+          </a:p>
+        </p:txBody>
+      </p:sp>
+    </p:spTree>
+    <p:extLst>
+      <p:ext uri="{BB962C8B-B14F-4D97-AF65-F5344CB8AC3E}">
+        <p14:creationId xmlns:p14="http://schemas.microsoft.com/office/powerpoint/2010/main" val="326419308"/>
       </p:ext>
     </p:extLst>
   </p:cSld>

</xml_diff>